<commit_message>
pipeline v6.1: canvas-filling layout (larger elements/fonts, legend pill, merged captions)
Co-Authored-By: Claude Fable 5 <noreply@anthropic.com>
</commit_message>
<xml_diff>
--- a/paper/figs/fig1_pipeline.pptx
+++ b/paper/figs/fig1_pipeline.pptx
@@ -3096,8 +3096,8 @@
         </p:nvSpPr>
         <p:spPr>
           <a:xfrm>
-            <a:off x="228600" y="201168"/>
-            <a:ext cx="310896" cy="310896"/>
+            <a:off x="228600" y="182880"/>
+            <a:ext cx="365760" cy="365760"/>
           </a:xfrm>
           <a:prstGeom prst="ellipse">
             <a:avLst/>
@@ -3116,7 +3116,7 @@
           <a:p>
             <a:pPr algn="ctr"/>
             <a:r>
-              <a:rPr sz="1300" b="1" i="0">
+              <a:rPr sz="1500" b="1" i="0">
                 <a:solidFill>
                   <a:srgbClr val="FFFFFF"/>
                 </a:solidFill>
@@ -3135,8 +3135,8 @@
         </p:nvSpPr>
         <p:spPr>
           <a:xfrm>
-            <a:off x="612647" y="219456"/>
-            <a:ext cx="2926080" cy="310896"/>
+            <a:off x="612647" y="201168"/>
+            <a:ext cx="2926080" cy="347472"/>
           </a:xfrm>
           <a:prstGeom prst="rect">
             <a:avLst/>
@@ -3151,7 +3151,7 @@
           <a:p>
             <a:pPr algn="l"/>
             <a:r>
-              <a:rPr sz="1400" b="1" i="0">
+              <a:rPr sz="1600" b="1" i="0">
                 <a:solidFill>
                   <a:srgbClr val="1F1F1E"/>
                 </a:solidFill>
@@ -3170,8 +3170,8 @@
         </p:nvSpPr>
         <p:spPr>
           <a:xfrm>
-            <a:off x="3291840" y="201168"/>
-            <a:ext cx="310896" cy="310896"/>
+            <a:off x="3291840" y="182880"/>
+            <a:ext cx="365760" cy="365760"/>
           </a:xfrm>
           <a:prstGeom prst="ellipse">
             <a:avLst/>
@@ -3190,7 +3190,7 @@
           <a:p>
             <a:pPr algn="ctr"/>
             <a:r>
-              <a:rPr sz="1300" b="1" i="0">
+              <a:rPr sz="1500" b="1" i="0">
                 <a:solidFill>
                   <a:srgbClr val="FFFFFF"/>
                 </a:solidFill>
@@ -3209,8 +3209,8 @@
         </p:nvSpPr>
         <p:spPr>
           <a:xfrm>
-            <a:off x="3675888" y="219456"/>
-            <a:ext cx="2926080" cy="310896"/>
+            <a:off x="3675888" y="201168"/>
+            <a:ext cx="2926080" cy="347472"/>
           </a:xfrm>
           <a:prstGeom prst="rect">
             <a:avLst/>
@@ -3225,7 +3225,7 @@
           <a:p>
             <a:pPr algn="l"/>
             <a:r>
-              <a:rPr sz="1400" b="1" i="0">
+              <a:rPr sz="1600" b="1" i="0">
                 <a:solidFill>
                   <a:srgbClr val="1F1F1E"/>
                 </a:solidFill>
@@ -3244,8 +3244,8 @@
         </p:nvSpPr>
         <p:spPr>
           <a:xfrm>
-            <a:off x="6309360" y="201168"/>
-            <a:ext cx="310896" cy="310896"/>
+            <a:off x="6309360" y="182880"/>
+            <a:ext cx="365760" cy="365760"/>
           </a:xfrm>
           <a:prstGeom prst="ellipse">
             <a:avLst/>
@@ -3264,7 +3264,7 @@
           <a:p>
             <a:pPr algn="ctr"/>
             <a:r>
-              <a:rPr sz="1300" b="1" i="0">
+              <a:rPr sz="1500" b="1" i="0">
                 <a:solidFill>
                   <a:srgbClr val="FFFFFF"/>
                 </a:solidFill>
@@ -3283,8 +3283,8 @@
         </p:nvSpPr>
         <p:spPr>
           <a:xfrm>
-            <a:off x="6693408" y="219456"/>
-            <a:ext cx="2926080" cy="310896"/>
+            <a:off x="6693408" y="201168"/>
+            <a:ext cx="2926080" cy="347472"/>
           </a:xfrm>
           <a:prstGeom prst="rect">
             <a:avLst/>
@@ -3299,7 +3299,7 @@
           <a:p>
             <a:pPr algn="l"/>
             <a:r>
-              <a:rPr sz="1400" b="1" i="0">
+              <a:rPr sz="1600" b="1" i="0">
                 <a:solidFill>
                   <a:srgbClr val="1F1F1E"/>
                 </a:solidFill>
@@ -3318,8 +3318,8 @@
         </p:nvSpPr>
         <p:spPr>
           <a:xfrm>
-            <a:off x="9281160" y="201168"/>
-            <a:ext cx="310896" cy="310896"/>
+            <a:off x="9281160" y="182880"/>
+            <a:ext cx="365760" cy="365760"/>
           </a:xfrm>
           <a:prstGeom prst="ellipse">
             <a:avLst/>
@@ -3338,7 +3338,7 @@
           <a:p>
             <a:pPr algn="ctr"/>
             <a:r>
-              <a:rPr sz="1300" b="1" i="0">
+              <a:rPr sz="1500" b="1" i="0">
                 <a:solidFill>
                   <a:srgbClr val="FFFFFF"/>
                 </a:solidFill>
@@ -3357,8 +3357,8 @@
         </p:nvSpPr>
         <p:spPr>
           <a:xfrm>
-            <a:off x="9665208" y="219456"/>
-            <a:ext cx="2926080" cy="310896"/>
+            <a:off x="9665208" y="201168"/>
+            <a:ext cx="2926080" cy="347472"/>
           </a:xfrm>
           <a:prstGeom prst="rect">
             <a:avLst/>
@@ -3373,7 +3373,7 @@
           <a:p>
             <a:pPr algn="l"/>
             <a:r>
-              <a:rPr sz="1400" b="1" i="0">
+              <a:rPr sz="1600" b="1" i="0">
                 <a:solidFill>
                   <a:srgbClr val="1F1F1E"/>
                 </a:solidFill>
@@ -3392,8 +3392,8 @@
         </p:nvSpPr>
         <p:spPr>
           <a:xfrm>
-            <a:off x="228600" y="2487168"/>
-            <a:ext cx="1298448" cy="877824"/>
+            <a:off x="274320" y="2103120"/>
+            <a:ext cx="1481328" cy="1234440"/>
           </a:xfrm>
           <a:prstGeom prst="roundRect">
             <a:avLst>
@@ -3403,7 +3403,7 @@
           <a:solidFill>
             <a:srgbClr val="F7F6F2"/>
           </a:solidFill>
-          <a:ln w="12700">
+          <a:ln w="15240">
             <a:solidFill>
               <a:srgbClr val="8C8C8C"/>
             </a:solidFill>
@@ -3426,8 +3426,8 @@
         </p:nvSpPr>
         <p:spPr>
           <a:xfrm>
-            <a:off x="310896" y="2569464"/>
-            <a:ext cx="1298448" cy="877824"/>
+            <a:off x="374904" y="2203703"/>
+            <a:ext cx="1481328" cy="1234440"/>
           </a:xfrm>
           <a:prstGeom prst="roundRect">
             <a:avLst>
@@ -3437,7 +3437,7 @@
           <a:solidFill>
             <a:srgbClr val="F7F6F2"/>
           </a:solidFill>
-          <a:ln w="12700">
+          <a:ln w="15240">
             <a:solidFill>
               <a:srgbClr val="8C8C8C"/>
             </a:solidFill>
@@ -3460,8 +3460,8 @@
         </p:nvSpPr>
         <p:spPr>
           <a:xfrm>
-            <a:off x="393192" y="2651760"/>
-            <a:ext cx="1298448" cy="877824"/>
+            <a:off x="475488" y="2304288"/>
+            <a:ext cx="1481328" cy="1234440"/>
           </a:xfrm>
           <a:prstGeom prst="roundRect">
             <a:avLst>
@@ -3471,7 +3471,7 @@
           <a:solidFill>
             <a:srgbClr val="F7F6F2"/>
           </a:solidFill>
-          <a:ln w="12700">
+          <a:ln w="15240">
             <a:solidFill>
               <a:srgbClr val="8C8C8C"/>
             </a:solidFill>
@@ -3494,8 +3494,8 @@
         </p:nvSpPr>
         <p:spPr>
           <a:xfrm>
-            <a:off x="256032" y="2194560"/>
-            <a:ext cx="1554480" cy="256032"/>
+            <a:off x="274320" y="1755648"/>
+            <a:ext cx="1828800" cy="292608"/>
           </a:xfrm>
           <a:prstGeom prst="rect">
             <a:avLst/>
@@ -3508,9 +3508,9 @@
           </a:bodyPr>
           <a:lstStyle/>
           <a:p>
-            <a:pPr algn="ctr"/>
-            <a:r>
-              <a:rPr sz="950" b="0" i="1">
+            <a:pPr algn="l"/>
+            <a:r>
+              <a:rPr sz="1200" b="0" i="1">
                 <a:solidFill>
                   <a:srgbClr val="6B6A63"/>
                 </a:solidFill>
@@ -3529,8 +3529,8 @@
         </p:nvSpPr>
         <p:spPr>
           <a:xfrm>
-            <a:off x="402336" y="2761488"/>
-            <a:ext cx="1170432" cy="548640"/>
+            <a:off x="502920" y="2487168"/>
+            <a:ext cx="1371600" cy="731520"/>
           </a:xfrm>
           <a:prstGeom prst="rect">
             <a:avLst/>
@@ -3545,7 +3545,7 @@
           <a:p>
             <a:pPr algn="l"/>
             <a:r>
-              <a:rPr sz="750" b="0" i="0">
+              <a:rPr sz="900" b="0" i="0">
                 <a:solidFill>
                   <a:srgbClr val="1F1F1E"/>
                 </a:solidFill>
@@ -3557,7 +3557,7 @@
           <a:p>
             <a:pPr algn="l"/>
             <a:r>
-              <a:rPr sz="750" b="0" i="0">
+              <a:rPr sz="900" b="0" i="0">
                 <a:solidFill>
                   <a:srgbClr val="1F1F1E"/>
                 </a:solidFill>
@@ -3576,8 +3576,8 @@
         </p:nvSpPr>
         <p:spPr>
           <a:xfrm>
-            <a:off x="1188720" y="3218688"/>
-            <a:ext cx="365760" cy="256032"/>
+            <a:off x="1389888" y="3127248"/>
+            <a:ext cx="457200" cy="310896"/>
           </a:xfrm>
           <a:prstGeom prst="rect">
             <a:avLst/>
@@ -3592,7 +3592,7 @@
           <a:p>
             <a:pPr algn="ctr"/>
             <a:r>
-              <a:rPr sz="1100" b="1" i="0">
+              <a:rPr sz="1300" b="1" i="0">
                 <a:solidFill>
                   <a:srgbClr val="6B6A63"/>
                 </a:solidFill>
@@ -3611,8 +3611,8 @@
         </p:nvSpPr>
         <p:spPr>
           <a:xfrm>
-            <a:off x="1719072" y="2734056"/>
-            <a:ext cx="786384" cy="566928"/>
+            <a:off x="1956816" y="2596896"/>
+            <a:ext cx="713232" cy="658368"/>
           </a:xfrm>
           <a:prstGeom prst="rightArrow">
             <a:avLst>
@@ -3634,7 +3634,7 @@
           <a:p>
             <a:pPr algn="ctr"/>
             <a:r>
-              <a:rPr sz="750" b="1" i="0">
+              <a:rPr sz="900" b="1" i="0">
                 <a:solidFill>
                   <a:srgbClr val="FFFFFF"/>
                 </a:solidFill>
@@ -3646,7 +3646,7 @@
           <a:p>
             <a:pPr algn="ctr"/>
             <a:r>
-              <a:rPr sz="750" b="1" i="0">
+              <a:rPr sz="900" b="1" i="0">
                 <a:solidFill>
                   <a:srgbClr val="FFFFFF"/>
                 </a:solidFill>
@@ -3665,8 +3665,8 @@
         </p:nvSpPr>
         <p:spPr>
           <a:xfrm>
-            <a:off x="2560320" y="2212848"/>
-            <a:ext cx="1444752" cy="1627632"/>
+            <a:off x="2724912" y="1691640"/>
+            <a:ext cx="1517904" cy="2331720"/>
           </a:xfrm>
           <a:prstGeom prst="roundRect">
             <a:avLst>
@@ -3676,7 +3676,7 @@
           <a:solidFill>
             <a:srgbClr val="FFFFFF"/>
           </a:solidFill>
-          <a:ln w="13970">
+          <a:ln w="15240">
             <a:solidFill>
               <a:srgbClr val="8C8C8C"/>
             </a:solidFill>
@@ -3699,8 +3699,8 @@
         </p:nvSpPr>
         <p:spPr>
           <a:xfrm>
-            <a:off x="2670048" y="2395728"/>
-            <a:ext cx="237744" cy="310896"/>
+            <a:off x="2834640" y="1920240"/>
+            <a:ext cx="274320" cy="402336"/>
           </a:xfrm>
           <a:prstGeom prst="roundRect">
             <a:avLst>
@@ -3710,7 +3710,7 @@
           <a:solidFill>
             <a:srgbClr val="F7F6F2"/>
           </a:solidFill>
-          <a:ln w="10160">
+          <a:ln w="11430">
             <a:solidFill>
               <a:srgbClr val="8C8C8C"/>
             </a:solidFill>
@@ -3733,8 +3733,8 @@
         </p:nvSpPr>
         <p:spPr>
           <a:xfrm>
-            <a:off x="2999232" y="2441448"/>
-            <a:ext cx="219456" cy="219456"/>
+            <a:off x="3200400" y="1984248"/>
+            <a:ext cx="237744" cy="237744"/>
           </a:xfrm>
           <a:prstGeom prst="roundRect">
             <a:avLst>
@@ -3767,8 +3767,8 @@
         </p:nvSpPr>
         <p:spPr>
           <a:xfrm>
-            <a:off x="3246120" y="2441448"/>
-            <a:ext cx="219456" cy="219456"/>
+            <a:off x="3456432" y="1984248"/>
+            <a:ext cx="237744" cy="237744"/>
           </a:xfrm>
           <a:prstGeom prst="roundRect">
             <a:avLst>
@@ -3801,8 +3801,8 @@
         </p:nvSpPr>
         <p:spPr>
           <a:xfrm>
-            <a:off x="3493008" y="2441448"/>
-            <a:ext cx="219456" cy="219456"/>
+            <a:off x="3712464" y="1984248"/>
+            <a:ext cx="237744" cy="237744"/>
           </a:xfrm>
           <a:prstGeom prst="roundRect">
             <a:avLst>
@@ -3835,8 +3835,8 @@
         </p:nvSpPr>
         <p:spPr>
           <a:xfrm>
-            <a:off x="3739896" y="2441448"/>
-            <a:ext cx="219456" cy="219456"/>
+            <a:off x="3968496" y="1984248"/>
+            <a:ext cx="237744" cy="237744"/>
           </a:xfrm>
           <a:prstGeom prst="roundRect">
             <a:avLst>
@@ -3869,8 +3869,8 @@
         </p:nvSpPr>
         <p:spPr>
           <a:xfrm>
-            <a:off x="2670048" y="2852928"/>
-            <a:ext cx="237744" cy="310896"/>
+            <a:off x="2834640" y="2578608"/>
+            <a:ext cx="274320" cy="402336"/>
           </a:xfrm>
           <a:prstGeom prst="roundRect">
             <a:avLst>
@@ -3880,7 +3880,7 @@
           <a:solidFill>
             <a:srgbClr val="F7F6F2"/>
           </a:solidFill>
-          <a:ln w="10160">
+          <a:ln w="11430">
             <a:solidFill>
               <a:srgbClr val="8C8C8C"/>
             </a:solidFill>
@@ -3903,8 +3903,8 @@
         </p:nvSpPr>
         <p:spPr>
           <a:xfrm>
-            <a:off x="2999232" y="2898648"/>
-            <a:ext cx="219456" cy="219456"/>
+            <a:off x="3200400" y="2642616"/>
+            <a:ext cx="237744" cy="237744"/>
           </a:xfrm>
           <a:prstGeom prst="roundRect">
             <a:avLst>
@@ -3937,8 +3937,8 @@
         </p:nvSpPr>
         <p:spPr>
           <a:xfrm>
-            <a:off x="3246120" y="2898648"/>
-            <a:ext cx="219456" cy="219456"/>
+            <a:off x="3456432" y="2642616"/>
+            <a:ext cx="237744" cy="237744"/>
           </a:xfrm>
           <a:prstGeom prst="roundRect">
             <a:avLst>
@@ -3971,8 +3971,8 @@
         </p:nvSpPr>
         <p:spPr>
           <a:xfrm>
-            <a:off x="3493008" y="2898648"/>
-            <a:ext cx="219456" cy="219456"/>
+            <a:off x="3712464" y="2642616"/>
+            <a:ext cx="237744" cy="237744"/>
           </a:xfrm>
           <a:prstGeom prst="roundRect">
             <a:avLst>
@@ -4005,8 +4005,8 @@
         </p:nvSpPr>
         <p:spPr>
           <a:xfrm>
-            <a:off x="3739896" y="2898648"/>
-            <a:ext cx="219456" cy="219456"/>
+            <a:off x="3968496" y="2642616"/>
+            <a:ext cx="237744" cy="237744"/>
           </a:xfrm>
           <a:prstGeom prst="roundRect">
             <a:avLst>
@@ -4039,8 +4039,8 @@
         </p:nvSpPr>
         <p:spPr>
           <a:xfrm>
-            <a:off x="2670048" y="3310128"/>
-            <a:ext cx="237744" cy="310896"/>
+            <a:off x="2834640" y="3236976"/>
+            <a:ext cx="274320" cy="402336"/>
           </a:xfrm>
           <a:prstGeom prst="roundRect">
             <a:avLst>
@@ -4050,7 +4050,7 @@
           <a:solidFill>
             <a:srgbClr val="F7F6F2"/>
           </a:solidFill>
-          <a:ln w="10160">
+          <a:ln w="11430">
             <a:solidFill>
               <a:srgbClr val="8C8C8C"/>
             </a:solidFill>
@@ -4073,8 +4073,8 @@
         </p:nvSpPr>
         <p:spPr>
           <a:xfrm>
-            <a:off x="2999232" y="3355848"/>
-            <a:ext cx="219456" cy="219456"/>
+            <a:off x="3200400" y="3300984"/>
+            <a:ext cx="237744" cy="237744"/>
           </a:xfrm>
           <a:prstGeom prst="roundRect">
             <a:avLst>
@@ -4107,8 +4107,8 @@
         </p:nvSpPr>
         <p:spPr>
           <a:xfrm>
-            <a:off x="3246120" y="3355848"/>
-            <a:ext cx="219456" cy="219456"/>
+            <a:off x="3456432" y="3300984"/>
+            <a:ext cx="237744" cy="237744"/>
           </a:xfrm>
           <a:prstGeom prst="roundRect">
             <a:avLst>
@@ -4141,8 +4141,8 @@
         </p:nvSpPr>
         <p:spPr>
           <a:xfrm>
-            <a:off x="3493008" y="3355848"/>
-            <a:ext cx="219456" cy="219456"/>
+            <a:off x="3712464" y="3300984"/>
+            <a:ext cx="237744" cy="237744"/>
           </a:xfrm>
           <a:prstGeom prst="roundRect">
             <a:avLst>
@@ -4175,8 +4175,8 @@
         </p:nvSpPr>
         <p:spPr>
           <a:xfrm>
-            <a:off x="3739896" y="3355848"/>
-            <a:ext cx="219456" cy="219456"/>
+            <a:off x="3968496" y="3300984"/>
+            <a:ext cx="237744" cy="237744"/>
           </a:xfrm>
           <a:prstGeom prst="roundRect">
             <a:avLst>
@@ -4209,8 +4209,8 @@
         </p:nvSpPr>
         <p:spPr>
           <a:xfrm>
-            <a:off x="2487168" y="3913632"/>
-            <a:ext cx="1600200" cy="457200"/>
+            <a:off x="2633472" y="4114800"/>
+            <a:ext cx="1737360" cy="310896"/>
           </a:xfrm>
           <a:prstGeom prst="rect">
             <a:avLst/>
@@ -4225,13 +4225,13 @@
           <a:p>
             <a:pPr algn="ctr"/>
             <a:r>
-              <a:rPr sz="900" b="1" i="0">
+              <a:rPr sz="1100" b="1" i="0">
                 <a:solidFill>
                   <a:srgbClr val="4C72B0"/>
                 </a:solidFill>
                 <a:latin typeface="Times New Roman"/>
               </a:rPr>
-              <a:t>needed skills light up (blue)</a:t>
+              <a:t>needed skills light up</a:t>
             </a:r>
           </a:p>
         </p:txBody>
@@ -4244,8 +4244,8 @@
         </p:nvSpPr>
         <p:spPr>
           <a:xfrm>
-            <a:off x="4059936" y="2734056"/>
-            <a:ext cx="731520" cy="566928"/>
+            <a:off x="4297680" y="2596896"/>
+            <a:ext cx="658368" cy="658368"/>
           </a:xfrm>
           <a:prstGeom prst="rightArrow">
             <a:avLst>
@@ -4267,7 +4267,7 @@
           <a:p>
             <a:pPr algn="ctr"/>
             <a:r>
-              <a:rPr sz="750" b="1" i="0">
+              <a:rPr sz="900" b="1" i="0">
                 <a:solidFill>
                   <a:srgbClr val="FFFFFF"/>
                 </a:solidFill>
@@ -4279,13 +4279,13 @@
           <a:p>
             <a:pPr algn="ctr"/>
             <a:r>
-              <a:rPr sz="750" b="1" i="0">
+              <a:rPr sz="900" b="1" i="0">
                 <a:solidFill>
                   <a:srgbClr val="FFFFFF"/>
                 </a:solidFill>
                 <a:latin typeface="Times New Roman"/>
               </a:rPr>
-              <a:t>dictionary</a:t>
+              <a:t>coding</a:t>
             </a:r>
           </a:p>
         </p:txBody>
@@ -4298,8 +4298,8 @@
         </p:nvSpPr>
         <p:spPr>
           <a:xfrm>
-            <a:off x="4846320" y="1901952"/>
-            <a:ext cx="1719072" cy="2048256"/>
+            <a:off x="5010912" y="1463040"/>
+            <a:ext cx="1810512" cy="2697480"/>
           </a:xfrm>
           <a:prstGeom prst="roundRect">
             <a:avLst>
@@ -4309,7 +4309,7 @@
           <a:solidFill>
             <a:srgbClr val="FFFFFF"/>
           </a:solidFill>
-          <a:ln w="13970">
+          <a:ln w="15240">
             <a:solidFill>
               <a:srgbClr val="8C8C8C"/>
             </a:solidFill>
@@ -4332,8 +4332,8 @@
         </p:nvSpPr>
         <p:spPr>
           <a:xfrm>
-            <a:off x="5001768" y="2084831"/>
-            <a:ext cx="237744" cy="237744"/>
+            <a:off x="5166360" y="1700784"/>
+            <a:ext cx="274320" cy="274320"/>
           </a:xfrm>
           <a:prstGeom prst="roundRect">
             <a:avLst>
@@ -4366,8 +4366,8 @@
         </p:nvSpPr>
         <p:spPr>
           <a:xfrm>
-            <a:off x="4960620" y="2043684"/>
-            <a:ext cx="320040" cy="320040"/>
+            <a:off x="5120640" y="1655064"/>
+            <a:ext cx="365760" cy="365760"/>
           </a:xfrm>
           <a:prstGeom prst="roundRect">
             <a:avLst>
@@ -4375,7 +4375,7 @@
             </a:avLst>
           </a:prstGeom>
           <a:noFill/>
-          <a:ln w="15240">
+          <a:ln w="16510">
             <a:solidFill>
               <a:srgbClr val="4C72B0"/>
             </a:solidFill>
@@ -4399,8 +4399,8 @@
         </p:nvSpPr>
         <p:spPr>
           <a:xfrm>
-            <a:off x="5294376" y="2084831"/>
-            <a:ext cx="237744" cy="237744"/>
+            <a:off x="5477256" y="1700784"/>
+            <a:ext cx="274320" cy="274320"/>
           </a:xfrm>
           <a:prstGeom prst="roundRect">
             <a:avLst>
@@ -4433,8 +4433,8 @@
         </p:nvSpPr>
         <p:spPr>
           <a:xfrm>
-            <a:off x="5586983" y="2084831"/>
-            <a:ext cx="237744" cy="237744"/>
+            <a:off x="5788152" y="1700784"/>
+            <a:ext cx="274320" cy="274320"/>
           </a:xfrm>
           <a:prstGeom prst="roundRect">
             <a:avLst>
@@ -4467,8 +4467,8 @@
         </p:nvSpPr>
         <p:spPr>
           <a:xfrm>
-            <a:off x="5879592" y="2084831"/>
-            <a:ext cx="237744" cy="237744"/>
+            <a:off x="6099048" y="1700784"/>
+            <a:ext cx="274320" cy="274320"/>
           </a:xfrm>
           <a:prstGeom prst="roundRect">
             <a:avLst>
@@ -4501,8 +4501,8 @@
         </p:nvSpPr>
         <p:spPr>
           <a:xfrm>
-            <a:off x="6172200" y="2084831"/>
-            <a:ext cx="237744" cy="237744"/>
+            <a:off x="6409944" y="1700784"/>
+            <a:ext cx="274320" cy="274320"/>
           </a:xfrm>
           <a:prstGeom prst="roundRect">
             <a:avLst>
@@ -4535,8 +4535,8 @@
         </p:nvSpPr>
         <p:spPr>
           <a:xfrm>
-            <a:off x="6131052" y="2043684"/>
-            <a:ext cx="320040" cy="320040"/>
+            <a:off x="6364224" y="1655064"/>
+            <a:ext cx="365760" cy="365760"/>
           </a:xfrm>
           <a:prstGeom prst="roundRect">
             <a:avLst>
@@ -4544,7 +4544,7 @@
             </a:avLst>
           </a:prstGeom>
           <a:noFill/>
-          <a:ln w="15240">
+          <a:ln w="16510">
             <a:solidFill>
               <a:srgbClr val="4C72B0"/>
             </a:solidFill>
@@ -4568,8 +4568,8 @@
         </p:nvSpPr>
         <p:spPr>
           <a:xfrm>
-            <a:off x="5001768" y="2633472"/>
-            <a:ext cx="237744" cy="237744"/>
+            <a:off x="5166360" y="2478024"/>
+            <a:ext cx="274320" cy="274320"/>
           </a:xfrm>
           <a:prstGeom prst="roundRect">
             <a:avLst>
@@ -4602,8 +4602,8 @@
         </p:nvSpPr>
         <p:spPr>
           <a:xfrm>
-            <a:off x="5294376" y="2633472"/>
-            <a:ext cx="237744" cy="237744"/>
+            <a:off x="5477256" y="2478024"/>
+            <a:ext cx="274320" cy="274320"/>
           </a:xfrm>
           <a:prstGeom prst="roundRect">
             <a:avLst>
@@ -4636,8 +4636,8 @@
         </p:nvSpPr>
         <p:spPr>
           <a:xfrm>
-            <a:off x="5253228" y="2592324"/>
-            <a:ext cx="320040" cy="320040"/>
+            <a:off x="5431536" y="2432304"/>
+            <a:ext cx="365760" cy="365760"/>
           </a:xfrm>
           <a:prstGeom prst="roundRect">
             <a:avLst>
@@ -4645,7 +4645,7 @@
             </a:avLst>
           </a:prstGeom>
           <a:noFill/>
-          <a:ln w="15240">
+          <a:ln w="16510">
             <a:solidFill>
               <a:srgbClr val="4C72B0"/>
             </a:solidFill>
@@ -4669,8 +4669,8 @@
         </p:nvSpPr>
         <p:spPr>
           <a:xfrm>
-            <a:off x="5586983" y="2633472"/>
-            <a:ext cx="237744" cy="237744"/>
+            <a:off x="5788152" y="2478024"/>
+            <a:ext cx="274320" cy="274320"/>
           </a:xfrm>
           <a:prstGeom prst="roundRect">
             <a:avLst>
@@ -4703,8 +4703,8 @@
         </p:nvSpPr>
         <p:spPr>
           <a:xfrm>
-            <a:off x="5879592" y="2633472"/>
-            <a:ext cx="237744" cy="237744"/>
+            <a:off x="6099048" y="2478024"/>
+            <a:ext cx="274320" cy="274320"/>
           </a:xfrm>
           <a:prstGeom prst="roundRect">
             <a:avLst>
@@ -4737,8 +4737,8 @@
         </p:nvSpPr>
         <p:spPr>
           <a:xfrm>
-            <a:off x="6172200" y="2633472"/>
-            <a:ext cx="237744" cy="237744"/>
+            <a:off x="6409944" y="2478024"/>
+            <a:ext cx="274320" cy="274320"/>
           </a:xfrm>
           <a:prstGeom prst="roundRect">
             <a:avLst>
@@ -4771,8 +4771,8 @@
         </p:nvSpPr>
         <p:spPr>
           <a:xfrm>
-            <a:off x="5001768" y="3182111"/>
-            <a:ext cx="237744" cy="237744"/>
+            <a:off x="5166360" y="3255264"/>
+            <a:ext cx="274320" cy="274320"/>
           </a:xfrm>
           <a:prstGeom prst="roundRect">
             <a:avLst>
@@ -4805,8 +4805,8 @@
         </p:nvSpPr>
         <p:spPr>
           <a:xfrm>
-            <a:off x="5294376" y="3182111"/>
-            <a:ext cx="237744" cy="237744"/>
+            <a:off x="5477256" y="3255264"/>
+            <a:ext cx="274320" cy="274320"/>
           </a:xfrm>
           <a:prstGeom prst="roundRect">
             <a:avLst>
@@ -4839,8 +4839,8 @@
         </p:nvSpPr>
         <p:spPr>
           <a:xfrm>
-            <a:off x="5586983" y="3182111"/>
-            <a:ext cx="237744" cy="237744"/>
+            <a:off x="5788152" y="3255264"/>
+            <a:ext cx="274320" cy="274320"/>
           </a:xfrm>
           <a:prstGeom prst="roundRect">
             <a:avLst>
@@ -4873,8 +4873,8 @@
         </p:nvSpPr>
         <p:spPr>
           <a:xfrm>
-            <a:off x="5545836" y="3140963"/>
-            <a:ext cx="320040" cy="320040"/>
+            <a:off x="5742432" y="3209544"/>
+            <a:ext cx="365760" cy="365760"/>
           </a:xfrm>
           <a:prstGeom prst="roundRect">
             <a:avLst>
@@ -4882,7 +4882,7 @@
             </a:avLst>
           </a:prstGeom>
           <a:noFill/>
-          <a:ln w="15240">
+          <a:ln w="16510">
             <a:solidFill>
               <a:srgbClr val="4C72B0"/>
             </a:solidFill>
@@ -4906,8 +4906,8 @@
         </p:nvSpPr>
         <p:spPr>
           <a:xfrm>
-            <a:off x="5879592" y="3182111"/>
-            <a:ext cx="237744" cy="237744"/>
+            <a:off x="6099048" y="3255264"/>
+            <a:ext cx="274320" cy="274320"/>
           </a:xfrm>
           <a:prstGeom prst="roundRect">
             <a:avLst>
@@ -4940,8 +4940,8 @@
         </p:nvSpPr>
         <p:spPr>
           <a:xfrm>
-            <a:off x="6172200" y="3182111"/>
-            <a:ext cx="237744" cy="237744"/>
+            <a:off x="6409944" y="3255264"/>
+            <a:ext cx="274320" cy="274320"/>
           </a:xfrm>
           <a:prstGeom prst="roundRect">
             <a:avLst>
@@ -4974,8 +4974,8 @@
         </p:nvSpPr>
         <p:spPr>
           <a:xfrm>
-            <a:off x="6131052" y="3140963"/>
-            <a:ext cx="320040" cy="320040"/>
+            <a:off x="6364224" y="3209544"/>
+            <a:ext cx="365760" cy="365760"/>
           </a:xfrm>
           <a:prstGeom prst="roundRect">
             <a:avLst>
@@ -4983,7 +4983,7 @@
             </a:avLst>
           </a:prstGeom>
           <a:noFill/>
-          <a:ln w="15240">
+          <a:ln w="16510">
             <a:solidFill>
               <a:srgbClr val="4C72B0"/>
             </a:solidFill>
@@ -5007,8 +5007,8 @@
         </p:nvSpPr>
         <p:spPr>
           <a:xfrm>
-            <a:off x="4846320" y="1645920"/>
-            <a:ext cx="1188720" cy="256032"/>
+            <a:off x="5010912" y="1115568"/>
+            <a:ext cx="1463040" cy="274320"/>
           </a:xfrm>
           <a:prstGeom prst="rect">
             <a:avLst/>
@@ -5023,7 +5023,7 @@
           <a:p>
             <a:pPr algn="l"/>
             <a:r>
-              <a:rPr sz="950" b="0" i="0">
+              <a:rPr sz="1100" b="0" i="0">
                 <a:solidFill>
                   <a:srgbClr val="6B6A63"/>
                 </a:solidFill>
@@ -5042,8 +5042,8 @@
         </p:nvSpPr>
         <p:spPr>
           <a:xfrm>
-            <a:off x="6144768" y="1810512"/>
-            <a:ext cx="1371600" cy="237744"/>
+            <a:off x="6309360" y="1481328"/>
+            <a:ext cx="1371600" cy="256032"/>
           </a:xfrm>
           <a:prstGeom prst="rect">
             <a:avLst/>
@@ -5058,7 +5058,7 @@
           <a:p>
             <a:pPr algn="l"/>
             <a:r>
-              <a:rPr sz="800" b="1" i="0">
+              <a:rPr sz="950" b="1" i="0">
                 <a:solidFill>
                   <a:srgbClr val="1F1F1E"/>
                 </a:solidFill>
@@ -5077,8 +5077,8 @@
         </p:nvSpPr>
         <p:spPr>
           <a:xfrm>
-            <a:off x="4681728" y="4059936"/>
-            <a:ext cx="2048256" cy="475488"/>
+            <a:off x="4846320" y="4279392"/>
+            <a:ext cx="2139696" cy="566928"/>
           </a:xfrm>
           <a:prstGeom prst="roundRect">
             <a:avLst>
@@ -5088,7 +5088,7 @@
           <a:solidFill>
             <a:srgbClr val="EEF2F9"/>
           </a:solidFill>
-          <a:ln w="16510">
+          <a:ln w="17780">
             <a:solidFill>
               <a:srgbClr val="4C72B0"/>
             </a:solidFill>
@@ -5101,7 +5101,7 @@
           <a:p>
             <a:pPr algn="ctr"/>
             <a:r>
-              <a:rPr sz="850" b="1" i="0">
+              <a:rPr sz="1000" b="1" i="0">
                 <a:solidFill>
                   <a:srgbClr val="4C72B0"/>
                 </a:solidFill>
@@ -5113,7 +5113,7 @@
           <a:p>
             <a:pPr algn="ctr"/>
             <a:r>
-              <a:rPr sz="850" b="1" i="0">
+              <a:rPr sz="1000" b="1" i="0">
                 <a:solidFill>
                   <a:srgbClr val="4C72B0"/>
                 </a:solidFill>
@@ -5132,8 +5132,8 @@
         </p:nvSpPr>
         <p:spPr>
           <a:xfrm>
-            <a:off x="6620256" y="2734056"/>
-            <a:ext cx="713232" cy="566928"/>
+            <a:off x="6876288" y="2596896"/>
+            <a:ext cx="640080" cy="658368"/>
           </a:xfrm>
           <a:prstGeom prst="rightArrow">
             <a:avLst>
@@ -5155,7 +5155,7 @@
           <a:p>
             <a:pPr algn="ctr"/>
             <a:r>
-              <a:rPr sz="750" b="1" i="0">
+              <a:rPr sz="900" b="1" i="0">
                 <a:solidFill>
                   <a:srgbClr val="FFFFFF"/>
                 </a:solidFill>
@@ -5167,7 +5167,7 @@
           <a:p>
             <a:pPr algn="ctr"/>
             <a:r>
-              <a:rPr sz="750" b="1" i="0">
+              <a:rPr sz="900" b="1" i="0">
                 <a:solidFill>
                   <a:srgbClr val="FFFFFF"/>
                 </a:solidFill>
@@ -5186,8 +5186,8 @@
         </p:nvSpPr>
         <p:spPr>
           <a:xfrm>
-            <a:off x="7562088" y="987551"/>
-            <a:ext cx="822960" cy="621792"/>
+            <a:off x="7731252" y="822960"/>
+            <a:ext cx="960120" cy="731520"/>
           </a:xfrm>
           <a:prstGeom prst="roundRect">
             <a:avLst>
@@ -5220,7 +5220,7 @@
         </p:nvSpPr>
         <p:spPr>
           <a:xfrm>
-            <a:off x="7962595" y="859535"/>
+            <a:off x="8200339" y="694944"/>
             <a:ext cx="21945" cy="128016"/>
           </a:xfrm>
           <a:prstGeom prst="rect">
@@ -5250,7 +5250,7 @@
         </p:nvSpPr>
         <p:spPr>
           <a:xfrm>
-            <a:off x="7927848" y="768095"/>
+            <a:off x="8165592" y="603504"/>
             <a:ext cx="91440" cy="91440"/>
           </a:xfrm>
           <a:prstGeom prst="ellipse">
@@ -5280,7 +5280,7 @@
         </p:nvSpPr>
         <p:spPr>
           <a:xfrm>
-            <a:off x="7784287" y="1195120"/>
+            <a:off x="7997342" y="1074420"/>
             <a:ext cx="82296" cy="82296"/>
           </a:xfrm>
           <a:prstGeom prst="ellipse">
@@ -5310,7 +5310,7 @@
         </p:nvSpPr>
         <p:spPr>
           <a:xfrm>
-            <a:off x="8080552" y="1195120"/>
+            <a:off x="8342985" y="1074420"/>
             <a:ext cx="82296" cy="82296"/>
           </a:xfrm>
           <a:prstGeom prst="ellipse">
@@ -5340,8 +5340,8 @@
         </p:nvSpPr>
         <p:spPr>
           <a:xfrm>
-            <a:off x="7858353" y="1373063"/>
-            <a:ext cx="230428" cy="27432"/>
+            <a:off x="8076895" y="1276502"/>
+            <a:ext cx="268833" cy="27432"/>
           </a:xfrm>
           <a:prstGeom prst="roundRect">
             <a:avLst>
@@ -5372,8 +5372,8 @@
         </p:nvSpPr>
         <p:spPr>
           <a:xfrm>
-            <a:off x="7242048" y="1645920"/>
-            <a:ext cx="1463040" cy="256032"/>
+            <a:off x="7411212" y="1591056"/>
+            <a:ext cx="1600200" cy="256032"/>
           </a:xfrm>
           <a:prstGeom prst="rect">
             <a:avLst/>
@@ -5388,7 +5388,7 @@
           <a:p>
             <a:pPr algn="ctr"/>
             <a:r>
-              <a:rPr sz="900" b="1" i="0">
+              <a:rPr sz="1050" b="1" i="0">
                 <a:solidFill>
                   <a:srgbClr val="1F1F1E"/>
                 </a:solidFill>
@@ -5407,8 +5407,8 @@
         </p:nvSpPr>
         <p:spPr>
           <a:xfrm>
-            <a:off x="7909560" y="1810512"/>
-            <a:ext cx="128016" cy="384048"/>
+            <a:off x="8147304" y="1810512"/>
+            <a:ext cx="146304" cy="365760"/>
           </a:xfrm>
           <a:prstGeom prst="downArrow">
             <a:avLst/>
@@ -5437,8 +5437,8 @@
         </p:nvSpPr>
         <p:spPr>
           <a:xfrm>
-            <a:off x="8083296" y="1874519"/>
-            <a:ext cx="914400" cy="237744"/>
+            <a:off x="8339327" y="1865376"/>
+            <a:ext cx="914400" cy="256032"/>
           </a:xfrm>
           <a:prstGeom prst="rect">
             <a:avLst/>
@@ -5453,7 +5453,7 @@
           <a:p>
             <a:pPr algn="l"/>
             <a:r>
-              <a:rPr sz="850" b="0" i="0">
+              <a:rPr sz="1000" b="0" i="0">
                 <a:solidFill>
                   <a:srgbClr val="6B6A63"/>
                 </a:solidFill>
@@ -5472,8 +5472,8 @@
         </p:nvSpPr>
         <p:spPr>
           <a:xfrm>
-            <a:off x="7388352" y="2267712"/>
-            <a:ext cx="1152144" cy="438912"/>
+            <a:off x="7571231" y="2286000"/>
+            <a:ext cx="1298448" cy="566928"/>
           </a:xfrm>
           <a:prstGeom prst="roundRect">
             <a:avLst>
@@ -5483,7 +5483,7 @@
           <a:solidFill>
             <a:srgbClr val="F7F6F2"/>
           </a:solidFill>
-          <a:ln w="15240">
+          <a:ln w="16510">
             <a:solidFill>
               <a:srgbClr val="4C72B0"/>
             </a:solidFill>
@@ -5506,8 +5506,8 @@
         </p:nvSpPr>
         <p:spPr>
           <a:xfrm>
-            <a:off x="7488936" y="2377440"/>
-            <a:ext cx="219456" cy="219456"/>
+            <a:off x="7699248" y="2432304"/>
+            <a:ext cx="274320" cy="274320"/>
           </a:xfrm>
           <a:prstGeom prst="roundRect">
             <a:avLst>
@@ -5540,8 +5540,8 @@
         </p:nvSpPr>
         <p:spPr>
           <a:xfrm>
-            <a:off x="7744967" y="2377440"/>
-            <a:ext cx="219456" cy="219456"/>
+            <a:off x="8001000" y="2432304"/>
+            <a:ext cx="274320" cy="274320"/>
           </a:xfrm>
           <a:prstGeom prst="roundRect">
             <a:avLst>
@@ -5574,8 +5574,8 @@
         </p:nvSpPr>
         <p:spPr>
           <a:xfrm>
-            <a:off x="8001000" y="2377440"/>
-            <a:ext cx="219456" cy="219456"/>
+            <a:off x="8302752" y="2432304"/>
+            <a:ext cx="274320" cy="274320"/>
           </a:xfrm>
           <a:prstGeom prst="roundRect">
             <a:avLst>
@@ -5608,8 +5608,8 @@
         </p:nvSpPr>
         <p:spPr>
           <a:xfrm>
-            <a:off x="7388352" y="2816352"/>
-            <a:ext cx="1152144" cy="438912"/>
+            <a:off x="7571231" y="2999232"/>
+            <a:ext cx="1298448" cy="566928"/>
           </a:xfrm>
           <a:prstGeom prst="roundRect">
             <a:avLst>
@@ -5619,7 +5619,7 @@
           <a:solidFill>
             <a:srgbClr val="F7F6F2"/>
           </a:solidFill>
-          <a:ln w="15240">
+          <a:ln w="16510">
             <a:solidFill>
               <a:srgbClr val="4C72B0"/>
             </a:solidFill>
@@ -5642,8 +5642,8 @@
         </p:nvSpPr>
         <p:spPr>
           <a:xfrm>
-            <a:off x="7488936" y="2926080"/>
-            <a:ext cx="219456" cy="219456"/>
+            <a:off x="7699248" y="3145536"/>
+            <a:ext cx="274320" cy="274320"/>
           </a:xfrm>
           <a:prstGeom prst="roundRect">
             <a:avLst>
@@ -5676,8 +5676,8 @@
         </p:nvSpPr>
         <p:spPr>
           <a:xfrm>
-            <a:off x="7744967" y="2926080"/>
-            <a:ext cx="219456" cy="219456"/>
+            <a:off x="8001000" y="3145536"/>
+            <a:ext cx="274320" cy="274320"/>
           </a:xfrm>
           <a:prstGeom prst="roundRect">
             <a:avLst>
@@ -5710,8 +5710,8 @@
         </p:nvSpPr>
         <p:spPr>
           <a:xfrm>
-            <a:off x="8001000" y="2926080"/>
-            <a:ext cx="219456" cy="219456"/>
+            <a:off x="8302752" y="3145536"/>
+            <a:ext cx="274320" cy="274320"/>
           </a:xfrm>
           <a:prstGeom prst="roundRect">
             <a:avLst>
@@ -5744,8 +5744,8 @@
         </p:nvSpPr>
         <p:spPr>
           <a:xfrm>
-            <a:off x="7388352" y="3364991"/>
-            <a:ext cx="1152144" cy="438912"/>
+            <a:off x="7571231" y="3712464"/>
+            <a:ext cx="1298448" cy="566928"/>
           </a:xfrm>
           <a:prstGeom prst="roundRect">
             <a:avLst>
@@ -5755,7 +5755,7 @@
           <a:solidFill>
             <a:srgbClr val="E8E6E1"/>
           </a:solidFill>
-          <a:ln w="15240">
+          <a:ln w="16510">
             <a:solidFill>
               <a:srgbClr val="8C8C8C"/>
             </a:solidFill>
@@ -5778,8 +5778,8 @@
         </p:nvSpPr>
         <p:spPr>
           <a:xfrm>
-            <a:off x="7488936" y="3474720"/>
-            <a:ext cx="219456" cy="219456"/>
+            <a:off x="7699248" y="3858768"/>
+            <a:ext cx="274320" cy="274320"/>
           </a:xfrm>
           <a:prstGeom prst="roundRect">
             <a:avLst>
@@ -5812,8 +5812,8 @@
         </p:nvSpPr>
         <p:spPr>
           <a:xfrm>
-            <a:off x="7744967" y="3474720"/>
-            <a:ext cx="219456" cy="219456"/>
+            <a:off x="8001000" y="3858768"/>
+            <a:ext cx="274320" cy="274320"/>
           </a:xfrm>
           <a:prstGeom prst="roundRect">
             <a:avLst>
@@ -5846,8 +5846,8 @@
         </p:nvSpPr>
         <p:spPr>
           <a:xfrm>
-            <a:off x="8001000" y="3474720"/>
-            <a:ext cx="219456" cy="219456"/>
+            <a:off x="8302752" y="3858768"/>
+            <a:ext cx="274320" cy="274320"/>
           </a:xfrm>
           <a:prstGeom prst="roundRect">
             <a:avLst>
@@ -5880,13 +5880,13 @@
         </p:nvCxnSpPr>
         <p:spPr>
           <a:xfrm flipV="1">
-            <a:off x="7315200" y="3328415"/>
-            <a:ext cx="1298448" cy="512064"/>
+            <a:off x="7498079" y="3657600"/>
+            <a:ext cx="1463041" cy="676656"/>
           </a:xfrm>
           <a:prstGeom prst="line">
             <a:avLst/>
           </a:prstGeom>
-          <a:ln w="25400">
+          <a:ln w="27940">
             <a:solidFill>
               <a:srgbClr val="C44E52"/>
             </a:solidFill>
@@ -5902,8 +5902,8 @@
         </p:nvSpPr>
         <p:spPr>
           <a:xfrm>
-            <a:off x="7114032" y="3950208"/>
-            <a:ext cx="1737360" cy="457200"/>
+            <a:off x="7333488" y="4498848"/>
+            <a:ext cx="1828800" cy="548640"/>
           </a:xfrm>
           <a:prstGeom prst="rect">
             <a:avLst/>
@@ -5918,7 +5918,7 @@
           <a:p>
             <a:pPr algn="ctr"/>
             <a:r>
-              <a:rPr sz="800" b="1" i="0">
+              <a:rPr sz="950" b="1" i="0">
                 <a:solidFill>
                   <a:srgbClr val="C44E52"/>
                 </a:solidFill>
@@ -5930,7 +5930,7 @@
           <a:p>
             <a:pPr algn="ctr"/>
             <a:r>
-              <a:rPr sz="800" b="1" i="0">
+              <a:rPr sz="950" b="1" i="0">
                 <a:solidFill>
                   <a:srgbClr val="C44E52"/>
                 </a:solidFill>
@@ -5949,8 +5949,8 @@
         </p:nvSpPr>
         <p:spPr>
           <a:xfrm>
-            <a:off x="8631936" y="2734056"/>
-            <a:ext cx="676656" cy="566928"/>
+            <a:off x="8979408" y="2596896"/>
+            <a:ext cx="603504" cy="658368"/>
           </a:xfrm>
           <a:prstGeom prst="rightArrow">
             <a:avLst>
@@ -5972,7 +5972,7 @@
           <a:p>
             <a:pPr algn="ctr"/>
             <a:r>
-              <a:rPr sz="750" b="1" i="0">
+              <a:rPr sz="900" b="1" i="0">
                 <a:solidFill>
                   <a:srgbClr val="FFFFFF"/>
                 </a:solidFill>
@@ -5984,7 +5984,7 @@
           <a:p>
             <a:pPr algn="ctr"/>
             <a:r>
-              <a:rPr sz="750" b="1" i="0">
+              <a:rPr sz="900" b="1" i="0">
                 <a:solidFill>
                   <a:srgbClr val="FFFFFF"/>
                 </a:solidFill>
@@ -6003,8 +6003,8 @@
         </p:nvSpPr>
         <p:spPr>
           <a:xfrm>
-            <a:off x="9290303" y="2551176"/>
-            <a:ext cx="841248" cy="658368"/>
+            <a:off x="9610344" y="2167128"/>
+            <a:ext cx="932688" cy="749808"/>
           </a:xfrm>
           <a:prstGeom prst="roundRect">
             <a:avLst>
@@ -6037,7 +6037,7 @@
         </p:nvSpPr>
         <p:spPr>
           <a:xfrm>
-            <a:off x="9699955" y="2423160"/>
+            <a:off x="10065715" y="2039112"/>
             <a:ext cx="21945" cy="128016"/>
           </a:xfrm>
           <a:prstGeom prst="rect">
@@ -6067,7 +6067,7 @@
         </p:nvSpPr>
         <p:spPr>
           <a:xfrm>
-            <a:off x="9665207" y="2331720"/>
+            <a:off x="10030967" y="1947672"/>
             <a:ext cx="91440" cy="91440"/>
           </a:xfrm>
           <a:prstGeom prst="ellipse">
@@ -6097,7 +6097,7 @@
         </p:nvSpPr>
         <p:spPr>
           <a:xfrm>
-            <a:off x="9518355" y="2773375"/>
+            <a:off x="9867656" y="2425903"/>
             <a:ext cx="82296" cy="82296"/>
           </a:xfrm>
           <a:prstGeom prst="ellipse">
@@ -6127,7 +6127,7 @@
         </p:nvSpPr>
         <p:spPr>
           <a:xfrm>
-            <a:off x="9821204" y="2773375"/>
+            <a:off x="10203423" y="2425903"/>
             <a:ext cx="82296" cy="82296"/>
           </a:xfrm>
           <a:prstGeom prst="ellipse">
@@ -6157,8 +6157,8 @@
         </p:nvSpPr>
         <p:spPr>
           <a:xfrm>
-            <a:off x="9593153" y="2959364"/>
-            <a:ext cx="235549" cy="27432"/>
+            <a:off x="9946111" y="2632008"/>
+            <a:ext cx="261152" cy="27432"/>
           </a:xfrm>
           <a:prstGeom prst="roundRect">
             <a:avLst>
@@ -6189,8 +6189,8 @@
         </p:nvSpPr>
         <p:spPr>
           <a:xfrm>
-            <a:off x="8970263" y="3246120"/>
-            <a:ext cx="1481328" cy="256032"/>
+            <a:off x="9290304" y="2953512"/>
+            <a:ext cx="1572768" cy="256032"/>
           </a:xfrm>
           <a:prstGeom prst="rect">
             <a:avLst/>
@@ -6205,7 +6205,7 @@
           <a:p>
             <a:pPr algn="ctr"/>
             <a:r>
-              <a:rPr sz="900" b="1" i="0">
+              <a:rPr sz="1050" b="1" i="0">
                 <a:solidFill>
                   <a:srgbClr val="1F1F1E"/>
                 </a:solidFill>
@@ -6224,8 +6224,8 @@
         </p:nvSpPr>
         <p:spPr>
           <a:xfrm>
-            <a:off x="9272016" y="3749039"/>
-            <a:ext cx="868680" cy="182880"/>
+            <a:off x="9582912" y="4041648"/>
+            <a:ext cx="969264" cy="219456"/>
           </a:xfrm>
           <a:prstGeom prst="roundRect">
             <a:avLst>
@@ -6235,7 +6235,7 @@
           <a:solidFill>
             <a:srgbClr val="FFFFFF"/>
           </a:solidFill>
-          <a:ln w="12700">
+          <a:ln w="13970">
             <a:solidFill>
               <a:srgbClr val="8C8C8C"/>
             </a:solidFill>
@@ -6258,8 +6258,8 @@
         </p:nvSpPr>
         <p:spPr>
           <a:xfrm>
-            <a:off x="9299448" y="3776472"/>
-            <a:ext cx="731520" cy="128016"/>
+            <a:off x="9610344" y="4069080"/>
+            <a:ext cx="822960" cy="164592"/>
           </a:xfrm>
           <a:prstGeom prst="roundRect">
             <a:avLst>
@@ -6290,8 +6290,8 @@
         </p:nvSpPr>
         <p:spPr>
           <a:xfrm>
-            <a:off x="10158984" y="3712463"/>
-            <a:ext cx="237744" cy="237744"/>
+            <a:off x="10570464" y="3986784"/>
+            <a:ext cx="274320" cy="274320"/>
           </a:xfrm>
           <a:prstGeom prst="ellipse">
             <a:avLst/>
@@ -6299,7 +6299,7 @@
           <a:solidFill>
             <a:srgbClr val="55A868"/>
           </a:solidFill>
-          <a:ln w="15240">
+          <a:ln w="16510">
             <a:solidFill>
               <a:srgbClr val="FFFFFF"/>
             </a:solidFill>
@@ -6312,7 +6312,7 @@
           <a:p>
             <a:pPr algn="ctr"/>
             <a:r>
-              <a:rPr sz="900" b="1" i="0">
+              <a:rPr sz="1000" b="1" i="0">
                 <a:solidFill>
                   <a:srgbClr val="FFFFFF"/>
                 </a:solidFill>
@@ -6331,8 +6331,8 @@
         </p:nvSpPr>
         <p:spPr>
           <a:xfrm>
-            <a:off x="9052560" y="4005072"/>
-            <a:ext cx="1463040" cy="237744"/>
+            <a:off x="9400032" y="4334256"/>
+            <a:ext cx="1554480" cy="256032"/>
           </a:xfrm>
           <a:prstGeom prst="rect">
             <a:avLst/>
@@ -6347,7 +6347,7 @@
           <a:p>
             <a:pPr algn="ctr"/>
             <a:r>
-              <a:rPr sz="800" b="0" i="0">
+              <a:rPr sz="950" b="0" i="0">
                 <a:solidFill>
                   <a:srgbClr val="6B6A63"/>
                 </a:solidFill>
@@ -6366,8 +6366,8 @@
         </p:nvSpPr>
         <p:spPr>
           <a:xfrm>
-            <a:off x="10277856" y="2734056"/>
-            <a:ext cx="566928" cy="566928"/>
+            <a:off x="10661904" y="2596896"/>
+            <a:ext cx="530352" cy="658368"/>
           </a:xfrm>
           <a:prstGeom prst="rightArrow">
             <a:avLst>
@@ -6389,7 +6389,7 @@
           <a:p>
             <a:pPr algn="ctr"/>
             <a:r>
-              <a:rPr sz="750" b="1" i="0">
+              <a:rPr sz="900" b="1" i="0">
                 <a:solidFill>
                   <a:srgbClr val="FFFFFF"/>
                 </a:solidFill>
@@ -6408,8 +6408,8 @@
         </p:nvSpPr>
         <p:spPr>
           <a:xfrm>
-            <a:off x="10917936" y="2212848"/>
-            <a:ext cx="182880" cy="1609344"/>
+            <a:off x="11247120" y="1920240"/>
+            <a:ext cx="201168" cy="2240280"/>
           </a:xfrm>
           <a:prstGeom prst="roundRect">
             <a:avLst>
@@ -6419,7 +6419,7 @@
           <a:solidFill>
             <a:srgbClr val="DFE5EF"/>
           </a:solidFill>
-          <a:ln w="13970">
+          <a:ln w="15240">
             <a:solidFill>
               <a:srgbClr val="4C72B0"/>
             </a:solidFill>
@@ -6442,8 +6442,8 @@
         </p:nvSpPr>
         <p:spPr>
           <a:xfrm>
-            <a:off x="11576304" y="2212848"/>
-            <a:ext cx="182880" cy="1609344"/>
+            <a:off x="11923776" y="1920240"/>
+            <a:ext cx="201168" cy="2240280"/>
           </a:xfrm>
           <a:prstGeom prst="roundRect">
             <a:avLst>
@@ -6453,7 +6453,7 @@
           <a:solidFill>
             <a:srgbClr val="DFE5EF"/>
           </a:solidFill>
-          <a:ln w="13970">
+          <a:ln w="15240">
             <a:solidFill>
               <a:srgbClr val="4C72B0"/>
             </a:solidFill>
@@ -6476,8 +6476,8 @@
         </p:nvSpPr>
         <p:spPr>
           <a:xfrm>
-            <a:off x="10853928" y="1993392"/>
-            <a:ext cx="969264" cy="256032"/>
+            <a:off x="11183112" y="1664208"/>
+            <a:ext cx="1005840" cy="274320"/>
           </a:xfrm>
           <a:prstGeom prst="roundRect">
             <a:avLst>
@@ -6487,7 +6487,7 @@
           <a:solidFill>
             <a:srgbClr val="DFE5EF"/>
           </a:solidFill>
-          <a:ln w="13970">
+          <a:ln w="15240">
             <a:solidFill>
               <a:srgbClr val="4C72B0"/>
             </a:solidFill>
@@ -6510,8 +6510,8 @@
         </p:nvSpPr>
         <p:spPr>
           <a:xfrm>
-            <a:off x="10991088" y="1828800"/>
-            <a:ext cx="384048" cy="384048"/>
+            <a:off x="11338560" y="1481328"/>
+            <a:ext cx="420624" cy="420624"/>
           </a:xfrm>
           <a:prstGeom prst="ellipse">
             <a:avLst/>
@@ -6519,7 +6519,7 @@
           <a:solidFill>
             <a:srgbClr val="55A868"/>
           </a:solidFill>
-          <a:ln w="17780">
+          <a:ln w="19050">
             <a:solidFill>
               <a:srgbClr val="FFFFFF"/>
             </a:solidFill>
@@ -6532,7 +6532,7 @@
           <a:p>
             <a:pPr algn="ctr"/>
             <a:r>
-              <a:rPr sz="850" b="1" i="0">
+              <a:rPr sz="950" b="1" i="0">
                 <a:solidFill>
                   <a:srgbClr val="FFFFFF"/>
                 </a:solidFill>
@@ -6551,8 +6551,8 @@
         </p:nvSpPr>
         <p:spPr>
           <a:xfrm>
-            <a:off x="10442448" y="1335024"/>
-            <a:ext cx="1737360" cy="457200"/>
+            <a:off x="10561320" y="987552"/>
+            <a:ext cx="1737360" cy="502920"/>
           </a:xfrm>
           <a:prstGeom prst="rect">
             <a:avLst/>
@@ -6567,7 +6567,7 @@
           <a:p>
             <a:pPr algn="ctr"/>
             <a:r>
-              <a:rPr sz="800" b="0" i="0">
+              <a:rPr sz="950" b="0" i="0">
                 <a:solidFill>
                   <a:srgbClr val="6B6A63"/>
                 </a:solidFill>
@@ -6579,7 +6579,7 @@
           <a:p>
             <a:pPr algn="ctr"/>
             <a:r>
-              <a:rPr sz="800" b="0" i="0">
+              <a:rPr sz="950" b="0" i="0">
                 <a:solidFill>
                   <a:srgbClr val="6B6A63"/>
                 </a:solidFill>
@@ -6598,13 +6598,13 @@
         </p:nvCxnSpPr>
         <p:spPr>
           <a:xfrm flipV="1">
-            <a:off x="11247120" y="2359152"/>
-            <a:ext cx="384048" cy="429768"/>
+            <a:off x="11356848" y="2286000"/>
+            <a:ext cx="393192" cy="411480"/>
           </a:xfrm>
           <a:prstGeom prst="line">
             <a:avLst/>
           </a:prstGeom>
-          <a:ln w="33020">
+          <a:ln w="35560">
             <a:solidFill>
               <a:srgbClr val="4C72B0"/>
             </a:solidFill>
@@ -6621,13 +6621,13 @@
         </p:nvCxnSpPr>
         <p:spPr>
           <a:xfrm>
-            <a:off x="11247120" y="3429000"/>
-            <a:ext cx="384048" cy="484632"/>
+            <a:off x="11356848" y="3383280"/>
+            <a:ext cx="393192" cy="475488"/>
           </a:xfrm>
           <a:prstGeom prst="line">
             <a:avLst/>
           </a:prstGeom>
-          <a:ln w="33020">
+          <a:ln w="35560">
             <a:solidFill>
               <a:srgbClr val="DD8452"/>
             </a:solidFill>
@@ -6644,8 +6644,8 @@
         </p:nvSpPr>
         <p:spPr>
           <a:xfrm>
-            <a:off x="11521440" y="1810512"/>
-            <a:ext cx="640080" cy="530352"/>
+            <a:off x="11475720" y="1810512"/>
+            <a:ext cx="694944" cy="603504"/>
           </a:xfrm>
           <a:prstGeom prst="roundRect">
             <a:avLst>
@@ -6655,7 +6655,7 @@
           <a:solidFill>
             <a:srgbClr val="EEF2F9"/>
           </a:solidFill>
-          <a:ln w="17780">
+          <a:ln w="19050">
             <a:solidFill>
               <a:srgbClr val="4C72B0"/>
             </a:solidFill>
@@ -6668,7 +6668,7 @@
           <a:p>
             <a:pPr algn="ctr"/>
             <a:r>
-              <a:rPr sz="800" b="1" i="0">
+              <a:rPr sz="900" b="1" i="0">
                 <a:solidFill>
                   <a:srgbClr val="4C72B0"/>
                 </a:solidFill>
@@ -6680,7 +6680,7 @@
           <a:p>
             <a:pPr algn="ctr"/>
             <a:r>
-              <a:rPr sz="800" b="1" i="0">
+              <a:rPr sz="900" b="1" i="0">
                 <a:solidFill>
                   <a:srgbClr val="4C72B0"/>
                 </a:solidFill>
@@ -6699,8 +6699,8 @@
         </p:nvSpPr>
         <p:spPr>
           <a:xfrm>
-            <a:off x="11521440" y="3858768"/>
-            <a:ext cx="640080" cy="530352"/>
+            <a:off x="11475720" y="3913632"/>
+            <a:ext cx="694944" cy="603504"/>
           </a:xfrm>
           <a:prstGeom prst="roundRect">
             <a:avLst>
@@ -6710,7 +6710,7 @@
           <a:solidFill>
             <a:srgbClr val="FDF0E7"/>
           </a:solidFill>
-          <a:ln w="17780">
+          <a:ln w="19050">
             <a:solidFill>
               <a:srgbClr val="DD8452"/>
             </a:solidFill>
@@ -6723,7 +6723,7 @@
           <a:p>
             <a:pPr algn="ctr"/>
             <a:r>
-              <a:rPr sz="800" b="1" i="0">
+              <a:rPr sz="900" b="1" i="0">
                 <a:solidFill>
                   <a:srgbClr val="DD8452"/>
                 </a:solidFill>
@@ -6735,7 +6735,7 @@
           <a:p>
             <a:pPr algn="ctr"/>
             <a:r>
-              <a:rPr sz="800" b="1" i="0">
+              <a:rPr sz="900" b="1" i="0">
                 <a:solidFill>
                   <a:srgbClr val="DD8452"/>
                 </a:solidFill>
@@ -6754,8 +6754,8 @@
         </p:nvSpPr>
         <p:spPr>
           <a:xfrm>
-            <a:off x="10332720" y="4553712"/>
-            <a:ext cx="1828800" cy="603504"/>
+            <a:off x="9464040" y="4956048"/>
+            <a:ext cx="2606040" cy="777240"/>
           </a:xfrm>
           <a:prstGeom prst="roundRect">
             <a:avLst>
@@ -6765,7 +6765,7 @@
           <a:solidFill>
             <a:srgbClr val="FFFFFF"/>
           </a:solidFill>
-          <a:ln w="19050">
+          <a:ln w="20320">
             <a:solidFill>
               <a:srgbClr val="55A868"/>
             </a:solidFill>
@@ -6778,7 +6778,7 @@
           <a:p>
             <a:pPr algn="ctr"/>
             <a:r>
-              <a:rPr sz="800" b="0" i="0">
+              <a:rPr sz="1050" b="0" i="0">
                 <a:solidFill>
                   <a:srgbClr val="1F1F1E"/>
                 </a:solidFill>
@@ -6790,7 +6790,7 @@
           <a:p>
             <a:pPr algn="ctr"/>
             <a:r>
-              <a:rPr sz="800" b="0" i="0">
+              <a:rPr sz="1050" b="0" i="0">
                 <a:solidFill>
                   <a:srgbClr val="1F1F1E"/>
                 </a:solidFill>
@@ -6809,8 +6809,8 @@
         </p:nvSpPr>
         <p:spPr>
           <a:xfrm>
-            <a:off x="1152144" y="5166360"/>
-            <a:ext cx="1920240" cy="457200"/>
+            <a:off x="182879" y="5349240"/>
+            <a:ext cx="1965960" cy="685800"/>
           </a:xfrm>
           <a:prstGeom prst="rect">
             <a:avLst/>
@@ -6825,25 +6825,37 @@
           <a:p>
             <a:pPr algn="ctr"/>
             <a:r>
-              <a:rPr sz="800" b="0" i="0">
+              <a:rPr sz="950" b="0" i="0">
                 <a:solidFill>
                   <a:srgbClr val="6B6A63"/>
                 </a:solidFill>
                 <a:latin typeface="Times New Roman"/>
               </a:rPr>
-              <a:t>one backward pass at the student's</a:t>
-            </a:r>
-          </a:p>
-          <a:p>
-            <a:pPr algn="ctr"/>
-            <a:r>
-              <a:rPr sz="800" b="0" i="0">
+              <a:t>one backward pass at the</a:t>
+            </a:r>
+          </a:p>
+          <a:p>
+            <a:pPr algn="ctr"/>
+            <a:r>
+              <a:rPr sz="950" b="0" i="0">
                 <a:solidFill>
                   <a:srgbClr val="6B6A63"/>
                 </a:solidFill>
                 <a:latin typeface="Times New Roman"/>
               </a:rPr>
-              <a:t>init reads each query's missing skills</a:t>
+              <a:t>student's init reads each</a:t>
+            </a:r>
+          </a:p>
+          <a:p>
+            <a:pPr algn="ctr"/>
+            <a:r>
+              <a:rPr sz="950" b="0" i="0">
+                <a:solidFill>
+                  <a:srgbClr val="6B6A63"/>
+                </a:solidFill>
+                <a:latin typeface="Times New Roman"/>
+              </a:rPr>
+              <a:t>query's missing skills</a:t>
             </a:r>
           </a:p>
         </p:txBody>
@@ -6856,8 +6868,8 @@
         </p:nvSpPr>
         <p:spPr>
           <a:xfrm>
-            <a:off x="3465576" y="5166360"/>
-            <a:ext cx="1920240" cy="457200"/>
+            <a:off x="2514600" y="5349240"/>
+            <a:ext cx="1965960" cy="685800"/>
           </a:xfrm>
           <a:prstGeom prst="rect">
             <a:avLst/>
@@ -6872,25 +6884,37 @@
           <a:p>
             <a:pPr algn="ctr"/>
             <a:r>
-              <a:rPr sz="800" b="0" i="0">
+              <a:rPr sz="950" b="0" i="0">
                 <a:solidFill>
                   <a:srgbClr val="6B6A63"/>
                 </a:solidFill>
                 <a:latin typeface="Times New Roman"/>
               </a:rPr>
-              <a:t>a sparse dictionary over many teacher</a:t>
-            </a:r>
-          </a:p>
-          <a:p>
-            <a:pPr algn="ctr"/>
-            <a:r>
-              <a:rPr sz="800" b="0" i="0">
+              <a:t>a sparse dictionary over</a:t>
+            </a:r>
+          </a:p>
+          <a:p>
+            <a:pPr algn="ctr"/>
+            <a:r>
+              <a:rPr sz="950" b="0" i="0">
                 <a:solidFill>
                   <a:srgbClr val="6B6A63"/>
                 </a:solidFill>
                 <a:latin typeface="Times New Roman"/>
               </a:rPr>
-              <a:t>traces factors gradients into atoms</a:t>
+              <a:t>many teacher traces factors</a:t>
+            </a:r>
+          </a:p>
+          <a:p>
+            <a:pPr algn="ctr"/>
+            <a:r>
+              <a:rPr sz="950" b="0" i="0">
+                <a:solidFill>
+                  <a:srgbClr val="6B6A63"/>
+                </a:solidFill>
+                <a:latin typeface="Times New Roman"/>
+              </a:rPr>
+              <a:t>gradients into skill atoms</a:t>
             </a:r>
           </a:p>
         </p:txBody>
@@ -6903,8 +6927,8 @@
         </p:nvSpPr>
         <p:spPr>
           <a:xfrm>
-            <a:off x="6016752" y="5166360"/>
-            <a:ext cx="1920240" cy="457200"/>
+            <a:off x="4937760" y="5349240"/>
+            <a:ext cx="1965960" cy="685800"/>
           </a:xfrm>
           <a:prstGeom prst="rect">
             <a:avLst/>
@@ -6919,25 +6943,37 @@
           <a:p>
             <a:pPr algn="ctr"/>
             <a:r>
-              <a:rPr sz="800" b="0" i="0">
+              <a:rPr sz="950" b="0" i="0">
                 <a:solidFill>
                   <a:srgbClr val="6B6A63"/>
                 </a:solidFill>
                 <a:latin typeface="Times New Roman"/>
               </a:rPr>
-              <a:t>traces are scored by the atoms they</a:t>
-            </a:r>
-          </a:p>
-          <a:p>
-            <a:pPr algn="ctr"/>
-            <a:r>
-              <a:rPr sz="800" b="0" i="0">
+              <a:t>the atoms the k queries</a:t>
+            </a:r>
+          </a:p>
+          <a:p>
+            <a:pPr algn="ctr"/>
+            <a:r>
+              <a:rPr sz="950" b="0" i="0">
                 <a:solidFill>
                   <a:srgbClr val="6B6A63"/>
                 </a:solidFill>
                 <a:latin typeface="Times New Roman"/>
               </a:rPr>
-              <a:t>supply; the budget is filled from the top</a:t>
+              <a:t>activate form the task</a:t>
+            </a:r>
+          </a:p>
+          <a:p>
+            <a:pPr algn="ctr"/>
+            <a:r>
+              <a:rPr sz="950" b="0" i="0">
+                <a:solidFill>
+                  <a:srgbClr val="6B6A63"/>
+                </a:solidFill>
+                <a:latin typeface="Times New Roman"/>
+              </a:rPr>
+              <a:t>specification</a:t>
             </a:r>
           </a:p>
         </p:txBody>
@@ -6950,8 +6986,8 @@
         </p:nvSpPr>
         <p:spPr>
           <a:xfrm>
-            <a:off x="8010144" y="5166360"/>
-            <a:ext cx="1920240" cy="457200"/>
+            <a:off x="7406640" y="5349240"/>
+            <a:ext cx="1965960" cy="685800"/>
           </a:xfrm>
           <a:prstGeom prst="rect">
             <a:avLst/>
@@ -6966,19 +7002,43 @@
           <a:p>
             <a:pPr algn="ctr"/>
             <a:r>
-              <a:rPr sz="800" b="0" i="0">
+              <a:rPr sz="950" b="0" i="0">
                 <a:solidFill>
                   <a:srgbClr val="6B6A63"/>
                 </a:solidFill>
                 <a:latin typeface="Times New Roman"/>
               </a:rPr>
-              <a:t>training stops once the remaining</a:t>
-            </a:r>
-          </a:p>
-          <a:p>
-            <a:pPr algn="ctr"/>
-            <a:r>
-              <a:rPr sz="800" b="0" i="0">
+              <a:t>traces are scored by the atoms</a:t>
+            </a:r>
+          </a:p>
+          <a:p>
+            <a:pPr algn="ctr"/>
+            <a:r>
+              <a:rPr sz="950" b="0" i="0">
+                <a:solidFill>
+                  <a:srgbClr val="6B6A63"/>
+                </a:solidFill>
+                <a:latin typeface="Times New Roman"/>
+              </a:rPr>
+              <a:t>they supply; the budget is filled</a:t>
+            </a:r>
+          </a:p>
+          <a:p>
+            <a:pPr algn="ctr"/>
+            <a:r>
+              <a:rPr sz="950" b="0" i="0">
+                <a:solidFill>
+                  <a:srgbClr val="6B6A63"/>
+                </a:solidFill>
+                <a:latin typeface="Times New Roman"/>
+              </a:rPr>
+              <a:t>from the top; stop once the</a:t>
+            </a:r>
+          </a:p>
+          <a:p>
+            <a:pPr algn="ctr"/>
+            <a:r>
+              <a:rPr sz="950" b="0" i="0">
                 <a:solidFill>
                   <a:srgbClr val="6B6A63"/>
                 </a:solidFill>
@@ -6991,48 +7051,33 @@
       </p:sp>
       <p:sp>
         <p:nvSpPr>
-          <p:cNvPr id="110" name="TextBox 109"/>
-          <p:cNvSpPr txBox="1"/>
-          <p:nvPr/>
-        </p:nvSpPr>
-        <p:spPr>
-          <a:xfrm>
-            <a:off x="9601200" y="5166360"/>
-            <a:ext cx="1920240" cy="457200"/>
-          </a:xfrm>
-          <a:prstGeom prst="rect">
-            <a:avLst/>
-          </a:prstGeom>
-          <a:noFill/>
-        </p:spPr>
-        <p:txBody>
-          <a:bodyPr wrap="square" lIns="0" rIns="0" tIns="0" bIns="0">
-            <a:spAutoFit/>
-          </a:bodyPr>
-          <a:lstStyle/>
-          <a:p>
-            <a:pPr algn="ctr"/>
-            <a:r>
-              <a:rPr sz="800" b="0" i="0">
-                <a:solidFill>
-                  <a:srgbClr val="6B6A63"/>
-                </a:solidFill>
-                <a:latin typeface="Times New Roman"/>
-              </a:rPr>
-              <a:t>a calibrated gate routes requests;</a:t>
-            </a:r>
-          </a:p>
-          <a:p>
-            <a:pPr algn="ctr"/>
-            <a:r>
-              <a:rPr sz="800" b="0" i="0">
-                <a:solidFill>
-                  <a:srgbClr val="6B6A63"/>
-                </a:solidFill>
-                <a:latin typeface="Times New Roman"/>
-              </a:rPr>
-              <a:t>both sides carry certificates</a:t>
-            </a:r>
+          <p:cNvPr id="110" name="Rounded Rectangle 109"/>
+          <p:cNvSpPr/>
+          <p:nvPr/>
+        </p:nvSpPr>
+        <p:spPr>
+          <a:xfrm>
+            <a:off x="3063240" y="6199632"/>
+            <a:ext cx="6766560" cy="457200"/>
+          </a:xfrm>
+          <a:prstGeom prst="roundRect">
+            <a:avLst>
+              <a:gd name="adj" fmla="val 50000"/>
+            </a:avLst>
+          </a:prstGeom>
+          <a:solidFill>
+            <a:srgbClr val="F7F6F2"/>
+          </a:solidFill>
+          <a:ln>
+            <a:noFill/>
+          </a:ln>
+          <a:effectLst/>
+        </p:spPr>
+        <p:txBody>
+          <a:bodyPr rtlCol="0" anchor="ctr"/>
+          <a:lstStyle/>
+          <a:p>
+            <a:pPr algn="ctr"/>
           </a:p>
         </p:txBody>
       </p:sp>
@@ -7044,8 +7089,8 @@
         </p:nvSpPr>
         <p:spPr>
           <a:xfrm>
-            <a:off x="411480" y="6291072"/>
-            <a:ext cx="219456" cy="219456"/>
+            <a:off x="3291840" y="6309360"/>
+            <a:ext cx="237744" cy="237744"/>
           </a:xfrm>
           <a:prstGeom prst="roundRect">
             <a:avLst>
@@ -7078,8 +7123,8 @@
         </p:nvSpPr>
         <p:spPr>
           <a:xfrm>
-            <a:off x="704088" y="6281928"/>
-            <a:ext cx="1554480" cy="256032"/>
+            <a:off x="3621024" y="6309360"/>
+            <a:ext cx="1600200" cy="274320"/>
           </a:xfrm>
           <a:prstGeom prst="rect">
             <a:avLst/>
@@ -7094,7 +7139,7 @@
           <a:p>
             <a:pPr algn="l"/>
             <a:r>
-              <a:rPr sz="950" b="0" i="0">
+              <a:rPr sz="1100" b="0" i="0">
                 <a:solidFill>
                   <a:srgbClr val="1F1F1E"/>
                 </a:solidFill>
@@ -7113,8 +7158,8 @@
         </p:nvSpPr>
         <p:spPr>
           <a:xfrm>
-            <a:off x="2221992" y="6291072"/>
-            <a:ext cx="219456" cy="219456"/>
+            <a:off x="5394960" y="6309360"/>
+            <a:ext cx="237744" cy="237744"/>
           </a:xfrm>
           <a:prstGeom prst="roundRect">
             <a:avLst>
@@ -7147,8 +7192,8 @@
         </p:nvSpPr>
         <p:spPr>
           <a:xfrm>
-            <a:off x="2514600" y="6281928"/>
-            <a:ext cx="1554480" cy="256032"/>
+            <a:off x="5724144" y="6309360"/>
+            <a:ext cx="1554480" cy="274320"/>
           </a:xfrm>
           <a:prstGeom prst="rect">
             <a:avLst/>
@@ -7163,7 +7208,7 @@
           <a:p>
             <a:pPr algn="l"/>
             <a:r>
-              <a:rPr sz="950" b="0" i="0">
+              <a:rPr sz="1100" b="0" i="0">
                 <a:solidFill>
                   <a:srgbClr val="1F1F1E"/>
                 </a:solidFill>
@@ -7182,8 +7227,8 @@
         </p:nvSpPr>
         <p:spPr>
           <a:xfrm>
-            <a:off x="3959352" y="6291072"/>
-            <a:ext cx="219456" cy="219456"/>
+            <a:off x="7452360" y="6309360"/>
+            <a:ext cx="237744" cy="237744"/>
           </a:xfrm>
           <a:prstGeom prst="roundRect">
             <a:avLst>
@@ -7216,8 +7261,8 @@
         </p:nvSpPr>
         <p:spPr>
           <a:xfrm>
-            <a:off x="4251960" y="6281928"/>
-            <a:ext cx="1097280" cy="256032"/>
+            <a:off x="7781544" y="6309360"/>
+            <a:ext cx="1097280" cy="274320"/>
           </a:xfrm>
           <a:prstGeom prst="rect">
             <a:avLst/>
@@ -7232,7 +7277,7 @@
           <a:p>
             <a:pPr algn="l"/>
             <a:r>
-              <a:rPr sz="950" b="0" i="0">
+              <a:rPr sz="1100" b="0" i="0">
                 <a:solidFill>
                   <a:srgbClr val="1F1F1E"/>
                 </a:solidFill>

</xml_diff>

<commit_message>
figs: v13 fonts +22% with overflow fixes
Co-Authored-By: Claude Fable 5 <noreply@anthropic.com>
</commit_message>
<xml_diff>
--- a/paper/figs/fig1_pipeline.pptx
+++ b/paper/figs/fig1_pipeline.pptx
@@ -3196,7 +3196,7 @@
           <a:p>
             <a:pPr algn="ctr"/>
             <a:r>
-              <a:rPr sz="1600" b="1" i="0">
+              <a:rPr sz="1950" b="1" i="0">
                 <a:solidFill>
                   <a:srgbClr val="FFFFFF"/>
                 </a:solidFill>
@@ -3231,7 +3231,7 @@
           <a:p>
             <a:pPr algn="l"/>
             <a:r>
-              <a:rPr sz="1800" b="1" i="1">
+              <a:rPr sz="2200" b="1" i="1">
                 <a:solidFill>
                   <a:srgbClr val="111111"/>
                 </a:solidFill>
@@ -3442,8 +3442,8 @@
         </p:nvSpPr>
         <p:spPr>
           <a:xfrm>
-            <a:off x="274320" y="2084831"/>
-            <a:ext cx="1828800" cy="292608"/>
+            <a:off x="182880" y="2103120"/>
+            <a:ext cx="2103120" cy="292608"/>
           </a:xfrm>
           <a:prstGeom prst="rect">
             <a:avLst/>
@@ -3458,13 +3458,13 @@
           <a:p>
             <a:pPr algn="ctr"/>
             <a:r>
-              <a:rPr sz="1200" b="1" i="1">
+              <a:rPr sz="1460" b="1" i="1">
                 <a:solidFill>
                   <a:srgbClr val="111111"/>
                 </a:solidFill>
                 <a:latin typeface="Times New Roman"/>
               </a:rPr>
-              <a:t>Support Set S (k queries)</a:t>
+              <a:t>Support Set S</a:t>
             </a:r>
           </a:p>
         </p:txBody>
@@ -3516,7 +3516,7 @@
           <a:p>
             <a:pPr algn="ctr"/>
             <a:r>
-              <a:rPr sz="2000" b="1" i="0">
+              <a:rPr sz="2440" b="1" i="0">
                 <a:solidFill>
                   <a:srgbClr val="111111"/>
                 </a:solidFill>
@@ -3737,7 +3737,7 @@
           <a:p>
             <a:pPr algn="ctr"/>
             <a:r>
-              <a:rPr sz="1300" b="1" i="0">
+              <a:rPr sz="1590" b="1" i="0">
                 <a:solidFill>
                   <a:srgbClr val="1F1F1E"/>
                 </a:solidFill>
@@ -4033,7 +4033,7 @@
           <a:p>
             <a:pPr algn="ctr"/>
             <a:r>
-              <a:rPr sz="1200" b="1" i="1">
+              <a:rPr sz="1460" b="1" i="1">
                 <a:solidFill>
                   <a:srgbClr val="111111"/>
                 </a:solidFill>
@@ -4076,7 +4076,7 @@
           <a:p>
             <a:pPr algn="ctr"/>
             <a:r>
-              <a:rPr sz="1700" b="1" i="0">
+              <a:rPr sz="2070" b="1" i="0">
                 <a:solidFill>
                   <a:srgbClr val="111111"/>
                 </a:solidFill>
@@ -4111,7 +4111,7 @@
           <a:p>
             <a:pPr algn="ctr"/>
             <a:r>
-              <a:rPr sz="1200" b="1" i="1">
+              <a:rPr sz="1460" b="1" i="1">
                 <a:solidFill>
                   <a:srgbClr val="111111"/>
                 </a:solidFill>
@@ -4203,7 +4203,7 @@
           <a:p>
             <a:pPr algn="ctr"/>
             <a:r>
-              <a:rPr sz="1050" b="1" i="1">
+              <a:rPr sz="1280" b="1" i="1">
                 <a:solidFill>
                   <a:srgbClr val="111111"/>
                 </a:solidFill>
@@ -4272,7 +4272,7 @@
           <a:p>
             <a:pPr algn="ctr"/>
             <a:r>
-              <a:rPr sz="1050" b="1" i="1">
+              <a:rPr sz="1280" b="1" i="1">
                 <a:solidFill>
                   <a:srgbClr val="111111"/>
                 </a:solidFill>
@@ -4341,7 +4341,7 @@
           <a:p>
             <a:pPr algn="ctr"/>
             <a:r>
-              <a:rPr sz="1050" b="1" i="1">
+              <a:rPr sz="1280" b="1" i="1">
                 <a:solidFill>
                   <a:srgbClr val="111111"/>
                 </a:solidFill>
@@ -4410,7 +4410,7 @@
           <a:p>
             <a:pPr algn="ctr"/>
             <a:r>
-              <a:rPr sz="1050" b="1" i="1">
+              <a:rPr sz="1280" b="1" i="1">
                 <a:solidFill>
                   <a:srgbClr val="111111"/>
                 </a:solidFill>
@@ -4479,7 +4479,7 @@
           <a:p>
             <a:pPr algn="ctr"/>
             <a:r>
-              <a:rPr sz="1050" b="1" i="1">
+              <a:rPr sz="1280" b="1" i="1">
                 <a:solidFill>
                   <a:srgbClr val="111111"/>
                 </a:solidFill>
@@ -4514,7 +4514,7 @@
           <a:p>
             <a:pPr algn="ctr"/>
             <a:r>
-              <a:rPr sz="1300" b="1" i="1">
+              <a:rPr sz="1590" b="1" i="1">
                 <a:solidFill>
                   <a:srgbClr val="111111"/>
                 </a:solidFill>
@@ -4810,7 +4810,7 @@
           <a:p>
             <a:pPr algn="ctr"/>
             <a:r>
-              <a:rPr sz="1300" b="1" i="1">
+              <a:rPr sz="1590" b="1" i="1">
                 <a:solidFill>
                   <a:srgbClr val="111111"/>
                 </a:solidFill>
@@ -4853,7 +4853,7 @@
           <a:p>
             <a:pPr algn="ctr"/>
             <a:r>
-              <a:rPr sz="1600" b="1" i="0">
+              <a:rPr sz="1950" b="1" i="0">
                 <a:solidFill>
                   <a:srgbClr val="111111"/>
                 </a:solidFill>
@@ -5018,7 +5018,7 @@
           <a:p>
             <a:pPr algn="l"/>
             <a:r>
-              <a:rPr sz="1300" b="1" i="1">
+              <a:rPr sz="1590" b="1" i="1">
                 <a:solidFill>
                   <a:srgbClr val="111111"/>
                 </a:solidFill>
@@ -5171,7 +5171,7 @@
           <a:p>
             <a:pPr algn="ctr"/>
             <a:r>
-              <a:rPr sz="1100" b="1" i="1">
+              <a:rPr sz="1340" b="1" i="1">
                 <a:solidFill>
                   <a:srgbClr val="111111"/>
                 </a:solidFill>
@@ -5551,7 +5551,7 @@
           <a:p>
             <a:pPr algn="ctr"/>
             <a:r>
-              <a:rPr sz="1100" b="1" i="1">
+              <a:rPr sz="1340" b="1" i="1">
                 <a:solidFill>
                   <a:srgbClr val="111111"/>
                 </a:solidFill>
@@ -5727,7 +5727,7 @@
           <a:p>
             <a:pPr algn="ctr"/>
             <a:r>
-              <a:rPr sz="1100" b="1" i="1">
+              <a:rPr sz="1340" b="1" i="1">
                 <a:solidFill>
                   <a:srgbClr val="111111"/>
                 </a:solidFill>
@@ -5762,7 +5762,7 @@
           <a:p>
             <a:pPr algn="ctr"/>
             <a:r>
-              <a:rPr sz="1050" b="1" i="1">
+              <a:rPr sz="1280" b="1" i="1">
                 <a:solidFill>
                   <a:srgbClr val="111111"/>
                 </a:solidFill>
@@ -5774,7 +5774,7 @@
           <a:p>
             <a:pPr algn="ctr"/>
             <a:r>
-              <a:rPr sz="1050" b="1" i="1">
+              <a:rPr sz="1280" b="1" i="1">
                 <a:solidFill>
                   <a:srgbClr val="111111"/>
                 </a:solidFill>
@@ -5813,7 +5813,7 @@
           <a:p>
             <a:pPr algn="ctr"/>
             <a:r>
-              <a:rPr sz="1600" b="1" i="0">
+              <a:rPr sz="1950" b="1" i="0">
                 <a:solidFill>
                   <a:srgbClr val="FFFFFF"/>
                 </a:solidFill>
@@ -5848,7 +5848,7 @@
           <a:p>
             <a:pPr algn="l"/>
             <a:r>
-              <a:rPr sz="1800" b="1" i="1">
+              <a:rPr sz="2200" b="1" i="1">
                 <a:solidFill>
                   <a:srgbClr val="111111"/>
                 </a:solidFill>
@@ -6069,7 +6069,7 @@
           <a:p>
             <a:pPr algn="ctr"/>
             <a:r>
-              <a:rPr sz="1300" b="1" i="0">
+              <a:rPr sz="1590" b="1" i="0">
                 <a:solidFill>
                   <a:srgbClr val="1F1F1E"/>
                 </a:solidFill>
@@ -6232,7 +6232,7 @@
           <a:p>
             <a:pPr algn="ctr"/>
             <a:r>
-              <a:rPr sz="1500" b="1" i="1">
+              <a:rPr sz="1830" b="1" i="1">
                 <a:solidFill>
                   <a:srgbClr val="111111"/>
                 </a:solidFill>
@@ -6414,7 +6414,7 @@
           <a:p>
             <a:pPr algn="ctr"/>
             <a:r>
-              <a:rPr sz="1150" b="1" i="1">
+              <a:rPr sz="1400" b="1" i="1">
                 <a:solidFill>
                   <a:srgbClr val="111111"/>
                 </a:solidFill>
@@ -6590,7 +6590,7 @@
           <a:p>
             <a:pPr algn="ctr"/>
             <a:r>
-              <a:rPr sz="1150" b="1" i="1">
+              <a:rPr sz="1400" b="1" i="1">
                 <a:solidFill>
                   <a:srgbClr val="111111"/>
                 </a:solidFill>
@@ -6632,7 +6632,7 @@
         </p:nvCxnSpPr>
         <p:spPr>
           <a:xfrm>
-            <a:off x="11109959" y="1645920"/>
+            <a:off x="11036807" y="1645920"/>
             <a:ext cx="658369" cy="0"/>
           </a:xfrm>
           <a:prstGeom prst="line">
@@ -6654,7 +6654,7 @@
         </p:nvSpPr>
         <p:spPr>
           <a:xfrm>
-            <a:off x="11155680" y="1143000"/>
+            <a:off x="11082528" y="1143000"/>
             <a:ext cx="155448" cy="502920"/>
           </a:xfrm>
           <a:prstGeom prst="rect">
@@ -6686,7 +6686,7 @@
         </p:nvSpPr>
         <p:spPr>
           <a:xfrm>
-            <a:off x="11361419" y="1508760"/>
+            <a:off x="11288267" y="1508760"/>
             <a:ext cx="155448" cy="137160"/>
           </a:xfrm>
           <a:prstGeom prst="rect">
@@ -6718,7 +6718,7 @@
         </p:nvSpPr>
         <p:spPr>
           <a:xfrm>
-            <a:off x="11567159" y="1371600"/>
+            <a:off x="11494007" y="1371600"/>
             <a:ext cx="155448" cy="274320"/>
           </a:xfrm>
           <a:prstGeom prst="rect">
@@ -6750,8 +6750,8 @@
         </p:nvSpPr>
         <p:spPr>
           <a:xfrm>
-            <a:off x="10927080" y="1828800"/>
-            <a:ext cx="1463040" cy="292608"/>
+            <a:off x="10835640" y="1828800"/>
+            <a:ext cx="1371600" cy="292608"/>
           </a:xfrm>
           <a:prstGeom prst="rect">
             <a:avLst/>
@@ -6766,7 +6766,7 @@
           <a:p>
             <a:pPr algn="ctr"/>
             <a:r>
-              <a:rPr sz="1150" b="1" i="1">
+              <a:rPr sz="1350" b="1" i="1">
                 <a:solidFill>
                   <a:srgbClr val="111111"/>
                 </a:solidFill>
@@ -6809,7 +6809,7 @@
           <a:p>
             <a:pPr algn="ctr"/>
             <a:r>
-              <a:rPr sz="1600" b="1" i="0">
+              <a:rPr sz="1950" b="1" i="0">
                 <a:solidFill>
                   <a:srgbClr val="111111"/>
                 </a:solidFill>
@@ -6911,7 +6911,7 @@
           <a:p>
             <a:pPr algn="ctr"/>
             <a:r>
-              <a:rPr sz="1150" b="1" i="1">
+              <a:rPr sz="1400" b="1" i="1">
                 <a:solidFill>
                   <a:srgbClr val="111111"/>
                 </a:solidFill>
@@ -6946,13 +6946,13 @@
           <a:p>
             <a:pPr algn="l"/>
             <a:r>
-              <a:rPr sz="1300" b="1" i="0">
+              <a:rPr sz="1500" b="1" i="0">
                 <a:solidFill>
                   <a:srgbClr val="111111"/>
                 </a:solidFill>
                 <a:latin typeface="Times New Roman"/>
               </a:rPr>
-              <a:t>returns → execution ✓ + prompt gate</a:t>
+              <a:t>returns → exec ✓ + gate</a:t>
             </a:r>
           </a:p>
         </p:txBody>
@@ -6987,7 +6987,7 @@
           <a:p>
             <a:pPr algn="ctr"/>
             <a:r>
-              <a:rPr sz="1500" b="1" i="0">
+              <a:rPr sz="1830" b="1" i="0">
                 <a:solidFill>
                   <a:srgbClr val="FFFFFF"/>
                 </a:solidFill>
@@ -7028,7 +7028,7 @@
           <a:p>
             <a:pPr algn="ctr"/>
             <a:r>
-              <a:rPr sz="1500" b="1" i="0">
+              <a:rPr sz="1830" b="1" i="0">
                 <a:solidFill>
                   <a:srgbClr val="FFFFFF"/>
                 </a:solidFill>
@@ -7063,7 +7063,7 @@
           <a:p>
             <a:pPr algn="l"/>
             <a:r>
-              <a:rPr sz="1300" b="1" i="0">
+              <a:rPr sz="1590" b="1" i="0">
                 <a:solidFill>
                   <a:srgbClr val="111111"/>
                 </a:solidFill>
@@ -7533,7 +7533,7 @@
           <a:p>
             <a:pPr algn="ctr"/>
             <a:r>
-              <a:rPr sz="1200" b="1" i="1">
+              <a:rPr sz="1460" b="1" i="1">
                 <a:solidFill>
                   <a:srgbClr val="111111"/>
                 </a:solidFill>
@@ -7568,7 +7568,7 @@
           <a:p>
             <a:pPr algn="ctr"/>
             <a:r>
-              <a:rPr sz="1200" b="1" i="1">
+              <a:rPr sz="1460" b="1" i="1">
                 <a:solidFill>
                   <a:srgbClr val="111111"/>
                 </a:solidFill>
@@ -7607,7 +7607,7 @@
           <a:p>
             <a:pPr algn="ctr"/>
             <a:r>
-              <a:rPr sz="1600" b="1" i="0">
+              <a:rPr sz="1950" b="1" i="0">
                 <a:solidFill>
                   <a:srgbClr val="FFFFFF"/>
                 </a:solidFill>
@@ -7626,8 +7626,8 @@
         </p:nvSpPr>
         <p:spPr>
           <a:xfrm>
-            <a:off x="6629400" y="4206240"/>
-            <a:ext cx="3291840" cy="292608"/>
+            <a:off x="6601968" y="4224528"/>
+            <a:ext cx="2926080" cy="292608"/>
           </a:xfrm>
           <a:prstGeom prst="rect">
             <a:avLst/>
@@ -7642,13 +7642,13 @@
           <a:p>
             <a:pPr algn="l"/>
             <a:r>
-              <a:rPr sz="1700" b="1" i="1">
+              <a:rPr sz="1900" b="1" i="1">
                 <a:solidFill>
                   <a:srgbClr val="111111"/>
                 </a:solidFill>
                 <a:latin typeface="Times New Roman"/>
               </a:rPr>
-              <a:t>Demand-weighted distillation</a:t>
+              <a:t>Weighted distillation</a:t>
             </a:r>
           </a:p>
         </p:txBody>
@@ -7661,7 +7661,7 @@
         </p:nvSpPr>
         <p:spPr>
           <a:xfrm>
-            <a:off x="9646920" y="4169663"/>
+            <a:off x="9528048" y="4169663"/>
             <a:ext cx="365760" cy="365760"/>
           </a:xfrm>
           <a:prstGeom prst="ellipse">
@@ -7681,7 +7681,7 @@
           <a:p>
             <a:pPr algn="ctr"/>
             <a:r>
-              <a:rPr sz="1600" b="1" i="0">
+              <a:rPr sz="1950" b="1" i="0">
                 <a:solidFill>
                   <a:srgbClr val="FFFFFF"/>
                 </a:solidFill>
@@ -7700,8 +7700,8 @@
         </p:nvSpPr>
         <p:spPr>
           <a:xfrm>
-            <a:off x="10104120" y="4206240"/>
-            <a:ext cx="2011680" cy="292608"/>
+            <a:off x="9985248" y="4224528"/>
+            <a:ext cx="2103120" cy="292608"/>
           </a:xfrm>
           <a:prstGeom prst="rect">
             <a:avLst/>
@@ -7716,7 +7716,7 @@
           <a:p>
             <a:pPr algn="l"/>
             <a:r>
-              <a:rPr sz="1700" b="1" i="1">
+              <a:rPr sz="1900" b="1" i="1">
                 <a:solidFill>
                   <a:srgbClr val="111111"/>
                 </a:solidFill>
@@ -8039,7 +8039,7 @@
           <a:p>
             <a:pPr algn="ctr"/>
             <a:r>
-              <a:rPr sz="1150" b="1" i="1">
+              <a:rPr sz="1400" b="1" i="1">
                 <a:solidFill>
                   <a:srgbClr val="111111"/>
                 </a:solidFill>
@@ -8283,7 +8283,7 @@
           <a:p>
             <a:pPr algn="ctr"/>
             <a:r>
-              <a:rPr sz="1200" b="1" i="0">
+              <a:rPr sz="1460" b="1" i="0">
                 <a:solidFill>
                   <a:srgbClr val="1F1F1E"/>
                 </a:solidFill>
@@ -8504,7 +8504,7 @@
           <a:p>
             <a:pPr algn="ctr"/>
             <a:r>
-              <a:rPr sz="1100" b="1" i="1">
+              <a:rPr sz="1340" b="1" i="1">
                 <a:solidFill>
                   <a:srgbClr val="111111"/>
                 </a:solidFill>
@@ -8579,7 +8579,7 @@
           <a:p>
             <a:pPr algn="ctr"/>
             <a:r>
-              <a:rPr sz="1800" b="1" i="0">
+              <a:rPr sz="2200" b="1" i="0">
                 <a:solidFill>
                   <a:srgbClr val="FFFFFF"/>
                 </a:solidFill>
@@ -8614,7 +8614,7 @@
           <a:p>
             <a:pPr algn="l"/>
             <a:r>
-              <a:rPr sz="1300" b="1" i="0">
+              <a:rPr sz="1590" b="1" i="0">
                 <a:solidFill>
                   <a:srgbClr val="111111"/>
                 </a:solidFill>
@@ -8626,7 +8626,7 @@
           <a:p>
             <a:pPr algn="l"/>
             <a:r>
-              <a:rPr sz="1300" b="1" i="0">
+              <a:rPr sz="1590" b="1" i="0">
                 <a:solidFill>
                   <a:srgbClr val="111111"/>
                 </a:solidFill>
@@ -8661,7 +8661,7 @@
           <a:p>
             <a:pPr algn="ctr"/>
             <a:r>
-              <a:rPr sz="1300" b="1" i="1">
+              <a:rPr sz="1590" b="1" i="1">
                 <a:solidFill>
                   <a:srgbClr val="111111"/>
                 </a:solidFill>
@@ -8728,7 +8728,7 @@
           <a:p>
             <a:pPr algn="l"/>
             <a:r>
-              <a:rPr sz="1200" b="1" i="0">
+              <a:rPr sz="1460" b="1" i="0">
                 <a:solidFill>
                   <a:srgbClr val="3E7A3A"/>
                 </a:solidFill>
@@ -8763,7 +8763,7 @@
           <a:p>
             <a:pPr algn="l"/>
             <a:r>
-              <a:rPr sz="1200" b="1" i="0">
+              <a:rPr sz="1460" b="1" i="0">
                 <a:solidFill>
                   <a:srgbClr val="8A5AA8"/>
                 </a:solidFill>

</xml_diff>

<commit_message>
figs: v13 generic atom labels a1..a5
Co-Authored-By: Claude Fable 5 <noreply@anthropic.com>
</commit_message>
<xml_diff>
--- a/paper/figs/fig1_pipeline.pptx
+++ b/paper/figs/fig1_pipeline.pptx
@@ -4209,7 +4209,7 @@
                 </a:solidFill>
                 <a:latin typeface="Times New Roman"/>
               </a:rPr>
-              <a:t>JOIN</a:t>
+              <a:t>a₁</a:t>
             </a:r>
           </a:p>
         </p:txBody>
@@ -4278,7 +4278,7 @@
                 </a:solidFill>
                 <a:latin typeface="Times New Roman"/>
               </a:rPr>
-              <a:t>AGG</a:t>
+              <a:t>a₂</a:t>
             </a:r>
           </a:p>
         </p:txBody>
@@ -4347,7 +4347,7 @@
                 </a:solidFill>
                 <a:latin typeface="Times New Roman"/>
               </a:rPr>
-              <a:t>LOOP</a:t>
+              <a:t>a₃</a:t>
             </a:r>
           </a:p>
         </p:txBody>
@@ -4416,7 +4416,7 @@
                 </a:solidFill>
                 <a:latin typeface="Times New Roman"/>
               </a:rPr>
-              <a:t>PLOT</a:t>
+              <a:t>a₄</a:t>
             </a:r>
           </a:p>
         </p:txBody>
@@ -4485,7 +4485,7 @@
                 </a:solidFill>
                 <a:latin typeface="Times New Roman"/>
               </a:rPr>
-              <a:t>REGEX</a:t>
+              <a:t>a₅</a:t>
             </a:r>
           </a:p>
         </p:txBody>

</xml_diff>

<commit_message>
figs: v13 final — larger icons, generic atoms, overlap fixes
Co-Authored-By: Claude Fable 5 <noreply@anthropic.com>
</commit_message>
<xml_diff>
--- a/paper/figs/fig1_pipeline.pptx
+++ b/paper/figs/fig1_pipeline.pptx
@@ -3177,7 +3177,7 @@
         <p:spPr>
           <a:xfrm>
             <a:off x="292608" y="237744"/>
-            <a:ext cx="365760" cy="365760"/>
+            <a:ext cx="457200" cy="457200"/>
           </a:xfrm>
           <a:prstGeom prst="ellipse">
             <a:avLst/>
@@ -3196,7 +3196,7 @@
           <a:p>
             <a:pPr algn="ctr"/>
             <a:r>
-              <a:rPr sz="1950" b="1" i="0">
+              <a:rPr sz="2200" b="1" i="0">
                 <a:solidFill>
                   <a:srgbClr val="FFFFFF"/>
                 </a:solidFill>
@@ -3215,7 +3215,7 @@
         </p:nvSpPr>
         <p:spPr>
           <a:xfrm>
-            <a:off x="749808" y="274320"/>
+            <a:off x="868680" y="292608"/>
             <a:ext cx="4937760" cy="292608"/>
           </a:xfrm>
           <a:prstGeom prst="rect">
@@ -3231,7 +3231,7 @@
           <a:p>
             <a:pPr algn="l"/>
             <a:r>
-              <a:rPr sz="2200" b="1" i="1">
+              <a:rPr sz="2000" b="1" i="1">
                 <a:solidFill>
                   <a:srgbClr val="111111"/>
                 </a:solidFill>
@@ -3251,7 +3251,7 @@
         <p:spPr>
           <a:xfrm>
             <a:off x="457200" y="841248"/>
-            <a:ext cx="914400" cy="1097280"/>
+            <a:ext cx="1078992" cy="1280160"/>
           </a:xfrm>
           <a:prstGeom prst="roundRect">
             <a:avLst>
@@ -3285,7 +3285,7 @@
         <p:spPr>
           <a:xfrm>
             <a:off x="621792" y="907084"/>
-            <a:ext cx="914400" cy="1097280"/>
+            <a:ext cx="1078992" cy="1280160"/>
           </a:xfrm>
           <a:prstGeom prst="roundRect">
             <a:avLst>
@@ -3319,7 +3319,7 @@
         <p:spPr>
           <a:xfrm>
             <a:off x="786384" y="972921"/>
-            <a:ext cx="914400" cy="1097280"/>
+            <a:ext cx="1078992" cy="1280160"/>
           </a:xfrm>
           <a:prstGeom prst="roundRect">
             <a:avLst>
@@ -3352,8 +3352,8 @@
         </p:nvSpPr>
         <p:spPr>
           <a:xfrm>
-            <a:off x="914400" y="1225296"/>
-            <a:ext cx="566928" cy="50292"/>
+            <a:off x="932688" y="1261872"/>
+            <a:ext cx="676656" cy="59436"/>
           </a:xfrm>
           <a:prstGeom prst="rect">
             <a:avLst/>
@@ -3382,8 +3382,8 @@
         </p:nvSpPr>
         <p:spPr>
           <a:xfrm>
-            <a:off x="914400" y="1426464"/>
-            <a:ext cx="566928" cy="50292"/>
+            <a:off x="932688" y="1499616"/>
+            <a:ext cx="676656" cy="59436"/>
           </a:xfrm>
           <a:prstGeom prst="rect">
             <a:avLst/>
@@ -3412,8 +3412,8 @@
         </p:nvSpPr>
         <p:spPr>
           <a:xfrm>
-            <a:off x="914400" y="1627632"/>
-            <a:ext cx="566928" cy="50292"/>
+            <a:off x="932688" y="1737360"/>
+            <a:ext cx="676656" cy="59436"/>
           </a:xfrm>
           <a:prstGeom prst="rect">
             <a:avLst/>
@@ -3442,7 +3442,7 @@
         </p:nvSpPr>
         <p:spPr>
           <a:xfrm>
-            <a:off x="182880" y="2103120"/>
+            <a:off x="228600" y="2304288"/>
             <a:ext cx="2103120" cy="292608"/>
           </a:xfrm>
           <a:prstGeom prst="rect">
@@ -3477,8 +3477,8 @@
         </p:nvCxnSpPr>
         <p:spPr>
           <a:xfrm>
-            <a:off x="1847088" y="1417320"/>
-            <a:ext cx="484632" cy="0"/>
+            <a:off x="1975104" y="1481328"/>
+            <a:ext cx="402336" cy="0"/>
           </a:xfrm>
           <a:prstGeom prst="line">
             <a:avLst/>
@@ -3500,8 +3500,8 @@
         </p:nvSpPr>
         <p:spPr>
           <a:xfrm>
-            <a:off x="1783080" y="1005840"/>
-            <a:ext cx="822960" cy="274320"/>
+            <a:off x="2212848" y="896112"/>
+            <a:ext cx="822960" cy="310896"/>
           </a:xfrm>
           <a:prstGeom prst="rect">
             <a:avLst/>
@@ -3516,7 +3516,7 @@
           <a:p>
             <a:pPr algn="ctr"/>
             <a:r>
-              <a:rPr sz="2440" b="1" i="0">
+              <a:rPr sz="2700" b="1" i="0">
                 <a:solidFill>
                   <a:srgbClr val="111111"/>
                 </a:solidFill>
@@ -3535,8 +3535,8 @@
         </p:nvSpPr>
         <p:spPr>
           <a:xfrm>
-            <a:off x="2350008" y="827532"/>
-            <a:ext cx="1188720" cy="1051560"/>
+            <a:off x="2308860" y="800100"/>
+            <a:ext cx="1417320" cy="1234440"/>
           </a:xfrm>
           <a:prstGeom prst="roundRect">
             <a:avLst>
@@ -3569,7 +3569,7 @@
         </p:nvSpPr>
         <p:spPr>
           <a:xfrm>
-            <a:off x="2933395" y="699516"/>
+            <a:off x="3006547" y="672084"/>
             <a:ext cx="21945" cy="128016"/>
           </a:xfrm>
           <a:prstGeom prst="rect">
@@ -3599,7 +3599,7 @@
         </p:nvSpPr>
         <p:spPr>
           <a:xfrm>
-            <a:off x="2898648" y="608076"/>
+            <a:off x="2971800" y="580644"/>
             <a:ext cx="91440" cy="91440"/>
           </a:xfrm>
           <a:prstGeom prst="ellipse">
@@ -3629,7 +3629,7 @@
         </p:nvSpPr>
         <p:spPr>
           <a:xfrm>
-            <a:off x="2689250" y="1207008"/>
+            <a:off x="2721254" y="1252728"/>
             <a:ext cx="82296" cy="82296"/>
           </a:xfrm>
           <a:prstGeom prst="ellipse">
@@ -3659,7 +3659,7 @@
         </p:nvSpPr>
         <p:spPr>
           <a:xfrm>
-            <a:off x="3117189" y="1207008"/>
+            <a:off x="3231489" y="1252728"/>
             <a:ext cx="82296" cy="82296"/>
           </a:xfrm>
           <a:prstGeom prst="ellipse">
@@ -3689,8 +3689,8 @@
         </p:nvSpPr>
         <p:spPr>
           <a:xfrm>
-            <a:off x="2777947" y="1479499"/>
-            <a:ext cx="332841" cy="27432"/>
+            <a:off x="2819095" y="1565452"/>
+            <a:ext cx="396849" cy="27432"/>
           </a:xfrm>
           <a:prstGeom prst="roundRect">
             <a:avLst>
@@ -3721,8 +3721,8 @@
         </p:nvSpPr>
         <p:spPr>
           <a:xfrm>
-            <a:off x="2029968" y="1915667"/>
-            <a:ext cx="1828800" cy="256032"/>
+            <a:off x="1988819" y="2071116"/>
+            <a:ext cx="2057400" cy="256032"/>
           </a:xfrm>
           <a:prstGeom prst="rect">
             <a:avLst/>
@@ -3737,7 +3737,7 @@
           <a:p>
             <a:pPr algn="ctr"/>
             <a:r>
-              <a:rPr sz="1590" b="1" i="0">
+              <a:rPr sz="1600" b="1" i="0">
                 <a:solidFill>
                   <a:srgbClr val="1F1F1E"/>
                 </a:solidFill>
@@ -3756,8 +3756,8 @@
         </p:nvCxnSpPr>
         <p:spPr>
           <a:xfrm>
-            <a:off x="3611880" y="1353312"/>
-            <a:ext cx="484632" cy="0"/>
+            <a:off x="3767328" y="1417320"/>
+            <a:ext cx="393192" cy="0"/>
           </a:xfrm>
           <a:prstGeom prst="line">
             <a:avLst/>
@@ -3779,8 +3779,8 @@
         </p:nvCxnSpPr>
         <p:spPr>
           <a:xfrm>
-            <a:off x="4178808" y="1792224"/>
-            <a:ext cx="864108" cy="0"/>
+            <a:off x="4233672" y="1901952"/>
+            <a:ext cx="1088136" cy="0"/>
           </a:xfrm>
           <a:prstGeom prst="line">
             <a:avLst/>
@@ -3801,8 +3801,8 @@
         </p:nvCxnSpPr>
         <p:spPr>
           <a:xfrm>
-            <a:off x="4178808" y="1645920"/>
-            <a:ext cx="864108" cy="0"/>
+            <a:off x="4233672" y="1755648"/>
+            <a:ext cx="1088136" cy="0"/>
           </a:xfrm>
           <a:prstGeom prst="line">
             <a:avLst/>
@@ -3823,8 +3823,8 @@
         </p:nvCxnSpPr>
         <p:spPr>
           <a:xfrm>
-            <a:off x="4178808" y="1499616"/>
-            <a:ext cx="864108" cy="0"/>
+            <a:off x="4233672" y="1609344"/>
+            <a:ext cx="1088136" cy="0"/>
           </a:xfrm>
           <a:prstGeom prst="line">
             <a:avLst/>
@@ -3845,8 +3845,8 @@
         </p:nvCxnSpPr>
         <p:spPr>
           <a:xfrm>
-            <a:off x="4178808" y="1353312"/>
-            <a:ext cx="864108" cy="0"/>
+            <a:off x="4233672" y="1463040"/>
+            <a:ext cx="1088136" cy="0"/>
           </a:xfrm>
           <a:prstGeom prst="line">
             <a:avLst/>
@@ -3867,8 +3867,8 @@
         </p:nvCxnSpPr>
         <p:spPr>
           <a:xfrm>
-            <a:off x="4178808" y="1810512"/>
-            <a:ext cx="864108" cy="0"/>
+            <a:off x="4233672" y="1920240"/>
+            <a:ext cx="1088135" cy="0"/>
           </a:xfrm>
           <a:prstGeom prst="line">
             <a:avLst/>
@@ -3889,8 +3889,8 @@
         </p:nvSpPr>
         <p:spPr>
           <a:xfrm>
-            <a:off x="4224528" y="1243584"/>
-            <a:ext cx="155448" cy="566928"/>
+            <a:off x="4279392" y="1243584"/>
+            <a:ext cx="201168" cy="676656"/>
           </a:xfrm>
           <a:prstGeom prst="rect">
             <a:avLst/>
@@ -3921,8 +3921,8 @@
         </p:nvSpPr>
         <p:spPr>
           <a:xfrm>
-            <a:off x="4430268" y="1536192"/>
-            <a:ext cx="155448" cy="274320"/>
+            <a:off x="4544568" y="1591056"/>
+            <a:ext cx="201168" cy="329184"/>
           </a:xfrm>
           <a:prstGeom prst="rect">
             <a:avLst/>
@@ -3953,8 +3953,8 @@
         </p:nvSpPr>
         <p:spPr>
           <a:xfrm>
-            <a:off x="4636008" y="1353312"/>
-            <a:ext cx="155448" cy="457200"/>
+            <a:off x="4809744" y="1371600"/>
+            <a:ext cx="201168" cy="548640"/>
           </a:xfrm>
           <a:prstGeom prst="rect">
             <a:avLst/>
@@ -3985,8 +3985,8 @@
         </p:nvSpPr>
         <p:spPr>
           <a:xfrm>
-            <a:off x="4841748" y="1609344"/>
-            <a:ext cx="155448" cy="201168"/>
+            <a:off x="5074920" y="1673352"/>
+            <a:ext cx="201168" cy="246888"/>
           </a:xfrm>
           <a:prstGeom prst="rect">
             <a:avLst/>
@@ -4017,8 +4017,8 @@
         </p:nvSpPr>
         <p:spPr>
           <a:xfrm>
-            <a:off x="3931920" y="2084831"/>
-            <a:ext cx="1737360" cy="292608"/>
+            <a:off x="3977639" y="2212848"/>
+            <a:ext cx="1828800" cy="292608"/>
           </a:xfrm>
           <a:prstGeom prst="rect">
             <a:avLst/>
@@ -4052,8 +4052,8 @@
         </p:nvSpPr>
         <p:spPr>
           <a:xfrm>
-            <a:off x="411480" y="2487168"/>
-            <a:ext cx="3520440" cy="512064"/>
+            <a:off x="411480" y="2670048"/>
+            <a:ext cx="3611880" cy="548640"/>
           </a:xfrm>
           <a:prstGeom prst="roundRect">
             <a:avLst>
@@ -4095,7 +4095,7 @@
         </p:nvSpPr>
         <p:spPr>
           <a:xfrm>
-            <a:off x="4023360" y="2596896"/>
+            <a:off x="4114800" y="2798064"/>
             <a:ext cx="1828800" cy="292608"/>
           </a:xfrm>
           <a:prstGeom prst="rect">
@@ -4130,8 +4130,8 @@
         </p:nvCxnSpPr>
         <p:spPr>
           <a:xfrm>
-            <a:off x="2148840" y="3017520"/>
-            <a:ext cx="0" cy="228600"/>
+            <a:off x="2194560" y="3236976"/>
+            <a:ext cx="0" cy="201168"/>
           </a:xfrm>
           <a:prstGeom prst="line">
             <a:avLst/>
@@ -4153,8 +4153,8 @@
         </p:nvSpPr>
         <p:spPr>
           <a:xfrm>
-            <a:off x="566928" y="3310128"/>
-            <a:ext cx="493776" cy="493776"/>
+            <a:off x="502920" y="3511296"/>
+            <a:ext cx="603504" cy="603504"/>
           </a:xfrm>
           <a:prstGeom prst="roundRect">
             <a:avLst>
@@ -4187,8 +4187,8 @@
         </p:nvSpPr>
         <p:spPr>
           <a:xfrm>
-            <a:off x="356616" y="3840480"/>
-            <a:ext cx="914400" cy="292608"/>
+            <a:off x="320040" y="4151376"/>
+            <a:ext cx="960120" cy="292608"/>
           </a:xfrm>
           <a:prstGeom prst="rect">
             <a:avLst/>
@@ -4203,7 +4203,7 @@
           <a:p>
             <a:pPr algn="ctr"/>
             <a:r>
-              <a:rPr sz="1280" b="1" i="1">
+              <a:rPr sz="1350" b="1" i="1">
                 <a:solidFill>
                   <a:srgbClr val="111111"/>
                 </a:solidFill>
@@ -4222,8 +4222,8 @@
         </p:nvSpPr>
         <p:spPr>
           <a:xfrm>
-            <a:off x="1225295" y="3310128"/>
-            <a:ext cx="493776" cy="493776"/>
+            <a:off x="1289304" y="3511296"/>
+            <a:ext cx="603504" cy="603504"/>
           </a:xfrm>
           <a:prstGeom prst="roundRect">
             <a:avLst>
@@ -4256,8 +4256,8 @@
         </p:nvSpPr>
         <p:spPr>
           <a:xfrm>
-            <a:off x="1014983" y="3840480"/>
-            <a:ext cx="914400" cy="292608"/>
+            <a:off x="1106424" y="4151376"/>
+            <a:ext cx="960120" cy="292608"/>
           </a:xfrm>
           <a:prstGeom prst="rect">
             <a:avLst/>
@@ -4272,7 +4272,7 @@
           <a:p>
             <a:pPr algn="ctr"/>
             <a:r>
-              <a:rPr sz="1280" b="1" i="1">
+              <a:rPr sz="1350" b="1" i="1">
                 <a:solidFill>
                   <a:srgbClr val="111111"/>
                 </a:solidFill>
@@ -4291,8 +4291,8 @@
         </p:nvSpPr>
         <p:spPr>
           <a:xfrm>
-            <a:off x="1883664" y="3310128"/>
-            <a:ext cx="493776" cy="493776"/>
+            <a:off x="2075688" y="3511296"/>
+            <a:ext cx="603504" cy="603504"/>
           </a:xfrm>
           <a:prstGeom prst="roundRect">
             <a:avLst>
@@ -4325,8 +4325,8 @@
         </p:nvSpPr>
         <p:spPr>
           <a:xfrm>
-            <a:off x="1673352" y="3840480"/>
-            <a:ext cx="914400" cy="292608"/>
+            <a:off x="1892807" y="4151376"/>
+            <a:ext cx="960120" cy="292608"/>
           </a:xfrm>
           <a:prstGeom prst="rect">
             <a:avLst/>
@@ -4341,7 +4341,7 @@
           <a:p>
             <a:pPr algn="ctr"/>
             <a:r>
-              <a:rPr sz="1280" b="1" i="1">
+              <a:rPr sz="1350" b="1" i="1">
                 <a:solidFill>
                   <a:srgbClr val="111111"/>
                 </a:solidFill>
@@ -4360,8 +4360,8 @@
         </p:nvSpPr>
         <p:spPr>
           <a:xfrm>
-            <a:off x="2542032" y="3310128"/>
-            <a:ext cx="493776" cy="493776"/>
+            <a:off x="2862072" y="3511296"/>
+            <a:ext cx="603504" cy="603504"/>
           </a:xfrm>
           <a:prstGeom prst="roundRect">
             <a:avLst>
@@ -4394,8 +4394,8 @@
         </p:nvSpPr>
         <p:spPr>
           <a:xfrm>
-            <a:off x="2331720" y="3840480"/>
-            <a:ext cx="914400" cy="292608"/>
+            <a:off x="2679191" y="4151376"/>
+            <a:ext cx="960120" cy="292608"/>
           </a:xfrm>
           <a:prstGeom prst="rect">
             <a:avLst/>
@@ -4410,7 +4410,7 @@
           <a:p>
             <a:pPr algn="ctr"/>
             <a:r>
-              <a:rPr sz="1280" b="1" i="1">
+              <a:rPr sz="1350" b="1" i="1">
                 <a:solidFill>
                   <a:srgbClr val="111111"/>
                 </a:solidFill>
@@ -4429,8 +4429,8 @@
         </p:nvSpPr>
         <p:spPr>
           <a:xfrm>
-            <a:off x="3200400" y="3310128"/>
-            <a:ext cx="493776" cy="493776"/>
+            <a:off x="3648456" y="3511296"/>
+            <a:ext cx="603504" cy="603504"/>
           </a:xfrm>
           <a:prstGeom prst="roundRect">
             <a:avLst>
@@ -4463,8 +4463,8 @@
         </p:nvSpPr>
         <p:spPr>
           <a:xfrm>
-            <a:off x="2990088" y="3840480"/>
-            <a:ext cx="914400" cy="292608"/>
+            <a:off x="3465576" y="4151376"/>
+            <a:ext cx="960120" cy="292608"/>
           </a:xfrm>
           <a:prstGeom prst="rect">
             <a:avLst/>
@@ -4479,7 +4479,7 @@
           <a:p>
             <a:pPr algn="ctr"/>
             <a:r>
-              <a:rPr sz="1280" b="1" i="1">
+              <a:rPr sz="1350" b="1" i="1">
                 <a:solidFill>
                   <a:srgbClr val="111111"/>
                 </a:solidFill>
@@ -4498,8 +4498,8 @@
         </p:nvSpPr>
         <p:spPr>
           <a:xfrm>
-            <a:off x="502920" y="4114800"/>
-            <a:ext cx="3291840" cy="292608"/>
+            <a:off x="548640" y="4462272"/>
+            <a:ext cx="3474720" cy="292608"/>
           </a:xfrm>
           <a:prstGeom prst="rect">
             <a:avLst/>
@@ -4533,8 +4533,8 @@
         </p:nvCxnSpPr>
         <p:spPr>
           <a:xfrm>
-            <a:off x="3977639" y="3566160"/>
-            <a:ext cx="338329" cy="0"/>
+            <a:off x="4480560" y="3803904"/>
+            <a:ext cx="256032" cy="0"/>
           </a:xfrm>
           <a:prstGeom prst="line">
             <a:avLst/>
@@ -4556,8 +4556,8 @@
         </p:nvCxnSpPr>
         <p:spPr>
           <a:xfrm>
-            <a:off x="4398264" y="3895344"/>
-            <a:ext cx="864108" cy="0"/>
+            <a:off x="4782312" y="4142232"/>
+            <a:ext cx="1088136" cy="0"/>
           </a:xfrm>
           <a:prstGeom prst="line">
             <a:avLst/>
@@ -4578,8 +4578,8 @@
         </p:nvCxnSpPr>
         <p:spPr>
           <a:xfrm>
-            <a:off x="4398264" y="3749040"/>
-            <a:ext cx="864108" cy="0"/>
+            <a:off x="4782312" y="3995928"/>
+            <a:ext cx="1088136" cy="0"/>
           </a:xfrm>
           <a:prstGeom prst="line">
             <a:avLst/>
@@ -4600,8 +4600,8 @@
         </p:nvCxnSpPr>
         <p:spPr>
           <a:xfrm>
-            <a:off x="4398264" y="3602736"/>
-            <a:ext cx="864108" cy="0"/>
+            <a:off x="4782312" y="3849624"/>
+            <a:ext cx="1088136" cy="0"/>
           </a:xfrm>
           <a:prstGeom prst="line">
             <a:avLst/>
@@ -4622,8 +4622,8 @@
         </p:nvCxnSpPr>
         <p:spPr>
           <a:xfrm>
-            <a:off x="4398264" y="3456432"/>
-            <a:ext cx="864108" cy="0"/>
+            <a:off x="4782312" y="3703320"/>
+            <a:ext cx="1088136" cy="0"/>
           </a:xfrm>
           <a:prstGeom prst="line">
             <a:avLst/>
@@ -4644,8 +4644,8 @@
         </p:nvCxnSpPr>
         <p:spPr>
           <a:xfrm>
-            <a:off x="4398264" y="3913632"/>
-            <a:ext cx="864108" cy="0"/>
+            <a:off x="4782312" y="4160520"/>
+            <a:ext cx="1088136" cy="0"/>
           </a:xfrm>
           <a:prstGeom prst="line">
             <a:avLst/>
@@ -4666,8 +4666,8 @@
         </p:nvSpPr>
         <p:spPr>
           <a:xfrm>
-            <a:off x="4443984" y="3310128"/>
-            <a:ext cx="155448" cy="603504"/>
+            <a:off x="4828032" y="3447287"/>
+            <a:ext cx="201168" cy="713232"/>
           </a:xfrm>
           <a:prstGeom prst="rect">
             <a:avLst/>
@@ -4698,8 +4698,8 @@
         </p:nvSpPr>
         <p:spPr>
           <a:xfrm>
-            <a:off x="4649724" y="3511296"/>
-            <a:ext cx="155448" cy="402336"/>
+            <a:off x="5093208" y="3685031"/>
+            <a:ext cx="201168" cy="475488"/>
           </a:xfrm>
           <a:prstGeom prst="rect">
             <a:avLst/>
@@ -4730,8 +4730,8 @@
         </p:nvSpPr>
         <p:spPr>
           <a:xfrm>
-            <a:off x="4855464" y="3657600"/>
-            <a:ext cx="155448" cy="256032"/>
+            <a:off x="5358384" y="3858768"/>
+            <a:ext cx="201168" cy="301752"/>
           </a:xfrm>
           <a:prstGeom prst="rect">
             <a:avLst/>
@@ -4762,8 +4762,8 @@
         </p:nvSpPr>
         <p:spPr>
           <a:xfrm>
-            <a:off x="5061204" y="3822192"/>
-            <a:ext cx="155448" cy="91440"/>
+            <a:off x="5623560" y="4050791"/>
+            <a:ext cx="201168" cy="109728"/>
           </a:xfrm>
           <a:prstGeom prst="rect">
             <a:avLst/>
@@ -4794,8 +4794,8 @@
         </p:nvSpPr>
         <p:spPr>
           <a:xfrm>
-            <a:off x="4160520" y="4160520"/>
-            <a:ext cx="1920240" cy="292608"/>
+            <a:off x="4773168" y="4526280"/>
+            <a:ext cx="1188720" cy="292608"/>
           </a:xfrm>
           <a:prstGeom prst="rect">
             <a:avLst/>
@@ -4810,7 +4810,7 @@
           <a:p>
             <a:pPr algn="ctr"/>
             <a:r>
-              <a:rPr sz="1590" b="1" i="1">
+              <a:rPr sz="1350" b="1" i="1">
                 <a:solidFill>
                   <a:srgbClr val="111111"/>
                 </a:solidFill>
@@ -4829,8 +4829,8 @@
         </p:nvSpPr>
         <p:spPr>
           <a:xfrm>
-            <a:off x="685800" y="4553712"/>
-            <a:ext cx="3931920" cy="475488"/>
+            <a:off x="548640" y="4828032"/>
+            <a:ext cx="4023360" cy="530352"/>
           </a:xfrm>
           <a:prstGeom prst="roundRect">
             <a:avLst>
@@ -4872,8 +4872,8 @@
         </p:nvSpPr>
         <p:spPr>
           <a:xfrm>
-            <a:off x="4800600" y="4892040"/>
-            <a:ext cx="384048" cy="96012"/>
+            <a:off x="4800600" y="5212080"/>
+            <a:ext cx="475488" cy="114300"/>
           </a:xfrm>
           <a:prstGeom prst="ellipse">
             <a:avLst/>
@@ -4904,8 +4904,8 @@
         </p:nvSpPr>
         <p:spPr>
           <a:xfrm>
-            <a:off x="4800600" y="4782312"/>
-            <a:ext cx="384048" cy="96012"/>
+            <a:off x="4800600" y="5084064"/>
+            <a:ext cx="475488" cy="114300"/>
           </a:xfrm>
           <a:prstGeom prst="ellipse">
             <a:avLst/>
@@ -4936,8 +4936,8 @@
         </p:nvSpPr>
         <p:spPr>
           <a:xfrm>
-            <a:off x="4800600" y="4672583"/>
-            <a:ext cx="384048" cy="96012"/>
+            <a:off x="4800600" y="4956048"/>
+            <a:ext cx="475488" cy="114300"/>
           </a:xfrm>
           <a:prstGeom prst="ellipse">
             <a:avLst/>
@@ -4968,8 +4968,8 @@
         </p:nvSpPr>
         <p:spPr>
           <a:xfrm>
-            <a:off x="365760" y="5257800"/>
-            <a:ext cx="5349240" cy="1325880"/>
+            <a:off x="365760" y="5504688"/>
+            <a:ext cx="5394960" cy="1188720"/>
           </a:xfrm>
           <a:prstGeom prst="roundRect">
             <a:avLst>
@@ -5002,7 +5002,7 @@
         </p:nvSpPr>
         <p:spPr>
           <a:xfrm>
-            <a:off x="502920" y="5321808"/>
+            <a:off x="502920" y="5541264"/>
             <a:ext cx="5029200" cy="292608"/>
           </a:xfrm>
           <a:prstGeom prst="rect">
@@ -5018,13 +5018,13 @@
           <a:p>
             <a:pPr algn="l"/>
             <a:r>
-              <a:rPr sz="1590" b="1" i="1">
+              <a:rPr sz="1500" b="1" i="1">
                 <a:solidFill>
                   <a:srgbClr val="111111"/>
                 </a:solidFill>
                 <a:latin typeface="Times New Roman"/>
               </a:rPr>
-              <a:t>Cross-modal bridge  (fit on paid pairs)</a:t>
+              <a:t>Cross-modal bridge (fit on paid pairs)</a:t>
             </a:r>
           </a:p>
         </p:txBody>
@@ -5037,8 +5037,8 @@
         </p:nvCxnSpPr>
         <p:spPr>
           <a:xfrm>
-            <a:off x="777240" y="6355080"/>
-            <a:ext cx="658368" cy="0"/>
+            <a:off x="731519" y="6419088"/>
+            <a:ext cx="822961" cy="0"/>
           </a:xfrm>
           <a:prstGeom prst="line">
             <a:avLst/>
@@ -5059,8 +5059,8 @@
         </p:nvSpPr>
         <p:spPr>
           <a:xfrm>
-            <a:off x="822960" y="6080760"/>
-            <a:ext cx="155448" cy="274320"/>
+            <a:off x="777240" y="6144768"/>
+            <a:ext cx="201168" cy="274320"/>
           </a:xfrm>
           <a:prstGeom prst="rect">
             <a:avLst/>
@@ -5091,8 +5091,8 @@
         </p:nvSpPr>
         <p:spPr>
           <a:xfrm>
-            <a:off x="1028700" y="5916168"/>
-            <a:ext cx="155448" cy="438912"/>
+            <a:off x="1042416" y="5980175"/>
+            <a:ext cx="201168" cy="438912"/>
           </a:xfrm>
           <a:prstGeom prst="rect">
             <a:avLst/>
@@ -5123,8 +5123,8 @@
         </p:nvSpPr>
         <p:spPr>
           <a:xfrm>
-            <a:off x="1234440" y="6153912"/>
-            <a:ext cx="155448" cy="201168"/>
+            <a:off x="1307592" y="6217920"/>
+            <a:ext cx="201168" cy="201168"/>
           </a:xfrm>
           <a:prstGeom prst="rect">
             <a:avLst/>
@@ -5155,8 +5155,8 @@
         </p:nvSpPr>
         <p:spPr>
           <a:xfrm>
-            <a:off x="502920" y="6400800"/>
-            <a:ext cx="1463040" cy="292608"/>
+            <a:off x="457200" y="6455664"/>
+            <a:ext cx="1554480" cy="292608"/>
           </a:xfrm>
           <a:prstGeom prst="rect">
             <a:avLst/>
@@ -5171,7 +5171,7 @@
           <a:p>
             <a:pPr algn="ctr"/>
             <a:r>
-              <a:rPr sz="1340" b="1" i="1">
+              <a:rPr sz="1200" b="1" i="1">
                 <a:solidFill>
                   <a:srgbClr val="111111"/>
                 </a:solidFill>
@@ -5190,8 +5190,8 @@
         </p:nvCxnSpPr>
         <p:spPr>
           <a:xfrm>
-            <a:off x="1645920" y="6126480"/>
-            <a:ext cx="502920" cy="0"/>
+            <a:off x="1783080" y="6172200"/>
+            <a:ext cx="411480" cy="0"/>
           </a:xfrm>
           <a:prstGeom prst="line">
             <a:avLst/>
@@ -5213,8 +5213,8 @@
         </p:nvSpPr>
         <p:spPr>
           <a:xfrm>
-            <a:off x="2240280" y="5742432"/>
-            <a:ext cx="713232" cy="713232"/>
+            <a:off x="2286000" y="5806440"/>
+            <a:ext cx="731520" cy="731520"/>
           </a:xfrm>
           <a:prstGeom prst="roundRect">
             <a:avLst>
@@ -5247,8 +5247,8 @@
         </p:nvSpPr>
         <p:spPr>
           <a:xfrm>
-            <a:off x="2313432" y="5815584"/>
-            <a:ext cx="158496" cy="158496"/>
+            <a:off x="2359152" y="5879592"/>
+            <a:ext cx="162560" cy="162560"/>
           </a:xfrm>
           <a:prstGeom prst="rect">
             <a:avLst/>
@@ -5279,8 +5279,8 @@
         </p:nvSpPr>
         <p:spPr>
           <a:xfrm>
-            <a:off x="2511552" y="5815584"/>
-            <a:ext cx="158496" cy="158496"/>
+            <a:off x="2562352" y="5879592"/>
+            <a:ext cx="162560" cy="162560"/>
           </a:xfrm>
           <a:prstGeom prst="rect">
             <a:avLst/>
@@ -5311,8 +5311,8 @@
         </p:nvSpPr>
         <p:spPr>
           <a:xfrm>
-            <a:off x="2709672" y="5815584"/>
-            <a:ext cx="158496" cy="158496"/>
+            <a:off x="2765552" y="5879592"/>
+            <a:ext cx="162560" cy="162560"/>
           </a:xfrm>
           <a:prstGeom prst="rect">
             <a:avLst/>
@@ -5343,8 +5343,8 @@
         </p:nvSpPr>
         <p:spPr>
           <a:xfrm>
-            <a:off x="2313432" y="6013704"/>
-            <a:ext cx="158496" cy="158496"/>
+            <a:off x="2359152" y="6082792"/>
+            <a:ext cx="162560" cy="162560"/>
           </a:xfrm>
           <a:prstGeom prst="rect">
             <a:avLst/>
@@ -5375,8 +5375,8 @@
         </p:nvSpPr>
         <p:spPr>
           <a:xfrm>
-            <a:off x="2511552" y="6013704"/>
-            <a:ext cx="158496" cy="158496"/>
+            <a:off x="2562352" y="6082792"/>
+            <a:ext cx="162560" cy="162560"/>
           </a:xfrm>
           <a:prstGeom prst="rect">
             <a:avLst/>
@@ -5407,8 +5407,8 @@
         </p:nvSpPr>
         <p:spPr>
           <a:xfrm>
-            <a:off x="2709672" y="6013704"/>
-            <a:ext cx="158496" cy="158496"/>
+            <a:off x="2765552" y="6082792"/>
+            <a:ext cx="162560" cy="162560"/>
           </a:xfrm>
           <a:prstGeom prst="rect">
             <a:avLst/>
@@ -5439,8 +5439,8 @@
         </p:nvSpPr>
         <p:spPr>
           <a:xfrm>
-            <a:off x="2313432" y="6211824"/>
-            <a:ext cx="158496" cy="158496"/>
+            <a:off x="2359152" y="6285992"/>
+            <a:ext cx="162560" cy="162560"/>
           </a:xfrm>
           <a:prstGeom prst="rect">
             <a:avLst/>
@@ -5471,8 +5471,8 @@
         </p:nvSpPr>
         <p:spPr>
           <a:xfrm>
-            <a:off x="2511552" y="6211824"/>
-            <a:ext cx="158496" cy="158496"/>
+            <a:off x="2562352" y="6285992"/>
+            <a:ext cx="162560" cy="162560"/>
           </a:xfrm>
           <a:prstGeom prst="rect">
             <a:avLst/>
@@ -5503,8 +5503,8 @@
         </p:nvSpPr>
         <p:spPr>
           <a:xfrm>
-            <a:off x="2709672" y="6211824"/>
-            <a:ext cx="158496" cy="158496"/>
+            <a:off x="2765552" y="6285992"/>
+            <a:ext cx="162560" cy="162560"/>
           </a:xfrm>
           <a:prstGeom prst="rect">
             <a:avLst/>
@@ -5535,8 +5535,8 @@
         </p:nvSpPr>
         <p:spPr>
           <a:xfrm>
-            <a:off x="2011680" y="6455664"/>
-            <a:ext cx="1188720" cy="292608"/>
+            <a:off x="2029968" y="6455664"/>
+            <a:ext cx="1280160" cy="292608"/>
           </a:xfrm>
           <a:prstGeom prst="rect">
             <a:avLst/>
@@ -5551,7 +5551,7 @@
           <a:p>
             <a:pPr algn="ctr"/>
             <a:r>
-              <a:rPr sz="1340" b="1" i="1">
+              <a:rPr sz="1200" b="1" i="1">
                 <a:solidFill>
                   <a:srgbClr val="111111"/>
                 </a:solidFill>
@@ -5570,8 +5570,8 @@
         </p:nvCxnSpPr>
         <p:spPr>
           <a:xfrm>
-            <a:off x="3108960" y="6126480"/>
-            <a:ext cx="502920" cy="0"/>
+            <a:off x="3200400" y="6172200"/>
+            <a:ext cx="411480" cy="0"/>
           </a:xfrm>
           <a:prstGeom prst="line">
             <a:avLst/>
@@ -5593,8 +5593,8 @@
         </p:nvCxnSpPr>
         <p:spPr>
           <a:xfrm>
-            <a:off x="3749040" y="6355080"/>
-            <a:ext cx="658368" cy="0"/>
+            <a:off x="3703320" y="6419088"/>
+            <a:ext cx="822959" cy="0"/>
           </a:xfrm>
           <a:prstGeom prst="line">
             <a:avLst/>
@@ -5615,8 +5615,8 @@
         </p:nvSpPr>
         <p:spPr>
           <a:xfrm>
-            <a:off x="3794760" y="5852160"/>
-            <a:ext cx="155448" cy="502920"/>
+            <a:off x="3749039" y="5916168"/>
+            <a:ext cx="201168" cy="502920"/>
           </a:xfrm>
           <a:prstGeom prst="rect">
             <a:avLst/>
@@ -5647,8 +5647,8 @@
         </p:nvSpPr>
         <p:spPr>
           <a:xfrm>
-            <a:off x="4000500" y="6126480"/>
-            <a:ext cx="155448" cy="228600"/>
+            <a:off x="4014215" y="6190488"/>
+            <a:ext cx="201168" cy="228600"/>
           </a:xfrm>
           <a:prstGeom prst="rect">
             <a:avLst/>
@@ -5679,8 +5679,8 @@
         </p:nvSpPr>
         <p:spPr>
           <a:xfrm>
-            <a:off x="4206240" y="5971032"/>
-            <a:ext cx="155448" cy="384048"/>
+            <a:off x="4279392" y="6035040"/>
+            <a:ext cx="201168" cy="384048"/>
           </a:xfrm>
           <a:prstGeom prst="rect">
             <a:avLst/>
@@ -5711,8 +5711,8 @@
         </p:nvSpPr>
         <p:spPr>
           <a:xfrm>
-            <a:off x="3520440" y="6400800"/>
-            <a:ext cx="1554480" cy="292608"/>
+            <a:off x="3566160" y="6455664"/>
+            <a:ext cx="1645920" cy="292608"/>
           </a:xfrm>
           <a:prstGeom prst="rect">
             <a:avLst/>
@@ -5727,7 +5727,7 @@
           <a:p>
             <a:pPr algn="ctr"/>
             <a:r>
-              <a:rPr sz="1340" b="1" i="1">
+              <a:rPr sz="1200" b="1" i="1">
                 <a:solidFill>
                   <a:srgbClr val="111111"/>
                 </a:solidFill>
@@ -5746,7 +5746,7 @@
         </p:nvSpPr>
         <p:spPr>
           <a:xfrm>
-            <a:off x="4892040" y="5806440"/>
+            <a:off x="4956048" y="5925312"/>
             <a:ext cx="868680" cy="548640"/>
           </a:xfrm>
           <a:prstGeom prst="rect">
@@ -5762,7 +5762,7 @@
           <a:p>
             <a:pPr algn="ctr"/>
             <a:r>
-              <a:rPr sz="1280" b="1" i="1">
+              <a:rPr sz="1200" b="1" i="1">
                 <a:solidFill>
                   <a:srgbClr val="111111"/>
                 </a:solidFill>
@@ -5774,7 +5774,7 @@
           <a:p>
             <a:pPr algn="ctr"/>
             <a:r>
-              <a:rPr sz="1280" b="1" i="1">
+              <a:rPr sz="1200" b="1" i="1">
                 <a:solidFill>
                   <a:srgbClr val="111111"/>
                 </a:solidFill>
@@ -5794,7 +5794,7 @@
         <p:spPr>
           <a:xfrm>
             <a:off x="6172200" y="237744"/>
-            <a:ext cx="365760" cy="365760"/>
+            <a:ext cx="457200" cy="457200"/>
           </a:xfrm>
           <a:prstGeom prst="ellipse">
             <a:avLst/>
@@ -5813,7 +5813,7 @@
           <a:p>
             <a:pPr algn="ctr"/>
             <a:r>
-              <a:rPr sz="1950" b="1" i="0">
+              <a:rPr sz="2200" b="1" i="0">
                 <a:solidFill>
                   <a:srgbClr val="FFFFFF"/>
                 </a:solidFill>
@@ -5832,8 +5832,8 @@
         </p:nvSpPr>
         <p:spPr>
           <a:xfrm>
-            <a:off x="6629400" y="274320"/>
-            <a:ext cx="5577840" cy="292608"/>
+            <a:off x="6766560" y="292608"/>
+            <a:ext cx="5394960" cy="292608"/>
           </a:xfrm>
           <a:prstGeom prst="rect">
             <a:avLst/>
@@ -5867,8 +5867,8 @@
         </p:nvSpPr>
         <p:spPr>
           <a:xfrm>
-            <a:off x="6309359" y="772668"/>
-            <a:ext cx="1188720" cy="1051560"/>
+            <a:off x="6240779" y="754380"/>
+            <a:ext cx="1417320" cy="1234440"/>
           </a:xfrm>
           <a:prstGeom prst="roundRect">
             <a:avLst>
@@ -5901,7 +5901,7 @@
         </p:nvSpPr>
         <p:spPr>
           <a:xfrm>
-            <a:off x="6892747" y="644652"/>
+            <a:off x="6938467" y="626364"/>
             <a:ext cx="21945" cy="128016"/>
           </a:xfrm>
           <a:prstGeom prst="rect">
@@ -5931,7 +5931,7 @@
         </p:nvSpPr>
         <p:spPr>
           <a:xfrm>
-            <a:off x="6858000" y="553212"/>
+            <a:off x="6903720" y="534924"/>
             <a:ext cx="91440" cy="91440"/>
           </a:xfrm>
           <a:prstGeom prst="ellipse">
@@ -5961,7 +5961,7 @@
         </p:nvSpPr>
         <p:spPr>
           <a:xfrm>
-            <a:off x="6648602" y="1152144"/>
+            <a:off x="6653174" y="1207008"/>
             <a:ext cx="82296" cy="82296"/>
           </a:xfrm>
           <a:prstGeom prst="ellipse">
@@ -5991,7 +5991,7 @@
         </p:nvSpPr>
         <p:spPr>
           <a:xfrm>
-            <a:off x="7076541" y="1152144"/>
+            <a:off x="7163409" y="1207008"/>
             <a:ext cx="82296" cy="82296"/>
           </a:xfrm>
           <a:prstGeom prst="ellipse">
@@ -6021,8 +6021,8 @@
         </p:nvSpPr>
         <p:spPr>
           <a:xfrm>
-            <a:off x="6737299" y="1424635"/>
-            <a:ext cx="332841" cy="27432"/>
+            <a:off x="6751015" y="1519732"/>
+            <a:ext cx="396849" cy="27432"/>
           </a:xfrm>
           <a:prstGeom prst="roundRect">
             <a:avLst>
@@ -6053,8 +6053,8 @@
         </p:nvSpPr>
         <p:spPr>
           <a:xfrm>
-            <a:off x="5989320" y="1860803"/>
-            <a:ext cx="1828800" cy="256032"/>
+            <a:off x="5920740" y="2025395"/>
+            <a:ext cx="2057400" cy="256032"/>
           </a:xfrm>
           <a:prstGeom prst="rect">
             <a:avLst/>
@@ -6069,7 +6069,7 @@
           <a:p>
             <a:pPr algn="ctr"/>
             <a:r>
-              <a:rPr sz="1590" b="1" i="0">
+              <a:rPr sz="1600" b="1" i="0">
                 <a:solidFill>
                   <a:srgbClr val="1F1F1E"/>
                 </a:solidFill>
@@ -6088,8 +6088,8 @@
         </p:nvSpPr>
         <p:spPr>
           <a:xfrm>
-            <a:off x="7589520" y="1188720"/>
-            <a:ext cx="384048" cy="96012"/>
+            <a:off x="7754112" y="1234440"/>
+            <a:ext cx="475488" cy="114300"/>
           </a:xfrm>
           <a:prstGeom prst="ellipse">
             <a:avLst/>
@@ -6120,8 +6120,8 @@
         </p:nvSpPr>
         <p:spPr>
           <a:xfrm>
-            <a:off x="7589520" y="1078992"/>
-            <a:ext cx="384048" cy="96012"/>
+            <a:off x="7754112" y="1106424"/>
+            <a:ext cx="475488" cy="114300"/>
           </a:xfrm>
           <a:prstGeom prst="ellipse">
             <a:avLst/>
@@ -6152,8 +6152,8 @@
         </p:nvSpPr>
         <p:spPr>
           <a:xfrm>
-            <a:off x="7589520" y="969264"/>
-            <a:ext cx="384048" cy="96012"/>
+            <a:off x="7754112" y="978408"/>
+            <a:ext cx="475488" cy="114300"/>
           </a:xfrm>
           <a:prstGeom prst="ellipse">
             <a:avLst/>
@@ -6184,8 +6184,8 @@
         </p:nvSpPr>
         <p:spPr>
           <a:xfrm>
-            <a:off x="7589520" y="859536"/>
-            <a:ext cx="384048" cy="96012"/>
+            <a:off x="7754112" y="850392"/>
+            <a:ext cx="475488" cy="114300"/>
           </a:xfrm>
           <a:prstGeom prst="ellipse">
             <a:avLst/>
@@ -6216,7 +6216,7 @@
         </p:nvSpPr>
         <p:spPr>
           <a:xfrm>
-            <a:off x="7571231" y="1353312"/>
+            <a:off x="7772400" y="1444752"/>
             <a:ext cx="822960" cy="292608"/>
           </a:xfrm>
           <a:prstGeom prst="rect">
@@ -6232,7 +6232,7 @@
           <a:p>
             <a:pPr algn="ctr"/>
             <a:r>
-              <a:rPr sz="1830" b="1" i="1">
+              <a:rPr sz="1900" b="1" i="1">
                 <a:solidFill>
                   <a:srgbClr val="111111"/>
                 </a:solidFill>
@@ -6251,8 +6251,8 @@
         </p:nvCxnSpPr>
         <p:spPr>
           <a:xfrm>
-            <a:off x="8092440" y="1298448"/>
-            <a:ext cx="411480" cy="0"/>
+            <a:off x="8321040" y="1371600"/>
+            <a:ext cx="292608" cy="0"/>
           </a:xfrm>
           <a:prstGeom prst="line">
             <a:avLst/>
@@ -6274,8 +6274,8 @@
         </p:nvSpPr>
         <p:spPr>
           <a:xfrm>
-            <a:off x="8577072" y="932688"/>
-            <a:ext cx="713232" cy="841248"/>
+            <a:off x="8686800" y="914400"/>
+            <a:ext cx="841248" cy="987552"/>
           </a:xfrm>
           <a:prstGeom prst="roundRect">
             <a:avLst>
@@ -6308,8 +6308,8 @@
         </p:nvSpPr>
         <p:spPr>
           <a:xfrm>
-            <a:off x="8686800" y="1115568"/>
-            <a:ext cx="475488" cy="45720"/>
+            <a:off x="8814816" y="1133856"/>
+            <a:ext cx="566928" cy="54864"/>
           </a:xfrm>
           <a:prstGeom prst="rect">
             <a:avLst/>
@@ -6338,8 +6338,8 @@
         </p:nvSpPr>
         <p:spPr>
           <a:xfrm>
-            <a:off x="8686800" y="1298448"/>
-            <a:ext cx="475488" cy="45720"/>
+            <a:off x="8814816" y="1353312"/>
+            <a:ext cx="566928" cy="54864"/>
           </a:xfrm>
           <a:prstGeom prst="rect">
             <a:avLst/>
@@ -6368,8 +6368,8 @@
         </p:nvSpPr>
         <p:spPr>
           <a:xfrm>
-            <a:off x="8686800" y="1481328"/>
-            <a:ext cx="475488" cy="45720"/>
+            <a:off x="8814816" y="1572768"/>
+            <a:ext cx="566928" cy="54864"/>
           </a:xfrm>
           <a:prstGeom prst="rect">
             <a:avLst/>
@@ -6398,8 +6398,8 @@
         </p:nvSpPr>
         <p:spPr>
           <a:xfrm>
-            <a:off x="8366760" y="1828800"/>
-            <a:ext cx="1188720" cy="292608"/>
+            <a:off x="8458200" y="1975104"/>
+            <a:ext cx="1280160" cy="292608"/>
           </a:xfrm>
           <a:prstGeom prst="rect">
             <a:avLst/>
@@ -6433,8 +6433,8 @@
         </p:nvCxnSpPr>
         <p:spPr>
           <a:xfrm>
-            <a:off x="9345168" y="1298448"/>
-            <a:ext cx="365760" cy="0"/>
+            <a:off x="9582912" y="1371600"/>
+            <a:ext cx="274320" cy="0"/>
           </a:xfrm>
           <a:prstGeom prst="line">
             <a:avLst/>
@@ -6456,8 +6456,8 @@
         </p:nvCxnSpPr>
         <p:spPr>
           <a:xfrm>
-            <a:off x="9784080" y="1645920"/>
-            <a:ext cx="658368" cy="0"/>
+            <a:off x="9902952" y="1783080"/>
+            <a:ext cx="822960" cy="0"/>
           </a:xfrm>
           <a:prstGeom prst="line">
             <a:avLst/>
@@ -6478,8 +6478,8 @@
         </p:nvSpPr>
         <p:spPr>
           <a:xfrm>
-            <a:off x="9829800" y="1261872"/>
-            <a:ext cx="155448" cy="384048"/>
+            <a:off x="9948672" y="1325880"/>
+            <a:ext cx="201168" cy="457200"/>
           </a:xfrm>
           <a:prstGeom prst="rect">
             <a:avLst/>
@@ -6510,8 +6510,8 @@
         </p:nvSpPr>
         <p:spPr>
           <a:xfrm>
-            <a:off x="10035540" y="1463040"/>
-            <a:ext cx="155448" cy="182880"/>
+            <a:off x="10213848" y="1563624"/>
+            <a:ext cx="201168" cy="219456"/>
           </a:xfrm>
           <a:prstGeom prst="rect">
             <a:avLst/>
@@ -6542,8 +6542,8 @@
         </p:nvSpPr>
         <p:spPr>
           <a:xfrm>
-            <a:off x="10241280" y="1335024"/>
-            <a:ext cx="155448" cy="310896"/>
+            <a:off x="10479024" y="1417319"/>
+            <a:ext cx="201168" cy="365760"/>
           </a:xfrm>
           <a:prstGeom prst="rect">
             <a:avLst/>
@@ -6574,8 +6574,8 @@
         </p:nvSpPr>
         <p:spPr>
           <a:xfrm>
-            <a:off x="9601200" y="1828800"/>
-            <a:ext cx="1463040" cy="292608"/>
+            <a:off x="9710928" y="1975104"/>
+            <a:ext cx="1554480" cy="292608"/>
           </a:xfrm>
           <a:prstGeom prst="rect">
             <a:avLst/>
@@ -6609,8 +6609,8 @@
         </p:nvCxnSpPr>
         <p:spPr>
           <a:xfrm>
-            <a:off x="10716768" y="1298448"/>
-            <a:ext cx="347472" cy="0"/>
+            <a:off x="10835640" y="1371600"/>
+            <a:ext cx="228600" cy="0"/>
           </a:xfrm>
           <a:prstGeom prst="line">
             <a:avLst/>
@@ -6632,8 +6632,8 @@
         </p:nvCxnSpPr>
         <p:spPr>
           <a:xfrm>
-            <a:off x="11036807" y="1645920"/>
-            <a:ext cx="658369" cy="0"/>
+            <a:off x="11091672" y="1783080"/>
+            <a:ext cx="822960" cy="0"/>
           </a:xfrm>
           <a:prstGeom prst="line">
             <a:avLst/>
@@ -6654,8 +6654,8 @@
         </p:nvSpPr>
         <p:spPr>
           <a:xfrm>
-            <a:off x="11082528" y="1143000"/>
-            <a:ext cx="155448" cy="502920"/>
+            <a:off x="11137392" y="1216152"/>
+            <a:ext cx="201168" cy="566928"/>
           </a:xfrm>
           <a:prstGeom prst="rect">
             <a:avLst/>
@@ -6686,8 +6686,8 @@
         </p:nvSpPr>
         <p:spPr>
           <a:xfrm>
-            <a:off x="11288267" y="1508760"/>
-            <a:ext cx="155448" cy="137160"/>
+            <a:off x="11402567" y="1618488"/>
+            <a:ext cx="201168" cy="164592"/>
           </a:xfrm>
           <a:prstGeom prst="rect">
             <a:avLst/>
@@ -6718,8 +6718,8 @@
         </p:nvSpPr>
         <p:spPr>
           <a:xfrm>
-            <a:off x="11494007" y="1371600"/>
-            <a:ext cx="155448" cy="274320"/>
+            <a:off x="11667744" y="1453895"/>
+            <a:ext cx="201168" cy="329184"/>
           </a:xfrm>
           <a:prstGeom prst="rect">
             <a:avLst/>
@@ -6750,7 +6750,7 @@
         </p:nvSpPr>
         <p:spPr>
           <a:xfrm>
-            <a:off x="10835640" y="1828800"/>
+            <a:off x="10927080" y="1975104"/>
             <a:ext cx="1371600" cy="292608"/>
           </a:xfrm>
           <a:prstGeom prst="rect">
@@ -6965,8 +6965,8 @@
         </p:nvSpPr>
         <p:spPr>
           <a:xfrm>
-            <a:off x="9464040" y="2871216"/>
-            <a:ext cx="402336" cy="402336"/>
+            <a:off x="9509760" y="2834640"/>
+            <a:ext cx="493776" cy="493776"/>
           </a:xfrm>
           <a:prstGeom prst="ellipse">
             <a:avLst/>
@@ -7006,8 +7006,8 @@
         </p:nvSpPr>
         <p:spPr>
           <a:xfrm>
-            <a:off x="9966960" y="2871216"/>
-            <a:ext cx="402336" cy="402336"/>
+            <a:off x="10104120" y="2834640"/>
+            <a:ext cx="493776" cy="493776"/>
           </a:xfrm>
           <a:prstGeom prst="ellipse">
             <a:avLst/>
@@ -7047,8 +7047,8 @@
         </p:nvSpPr>
         <p:spPr>
           <a:xfrm>
-            <a:off x="10469880" y="2907792"/>
-            <a:ext cx="1645920" cy="329184"/>
+            <a:off x="10716768" y="2907792"/>
+            <a:ext cx="1463040" cy="329184"/>
           </a:xfrm>
           <a:prstGeom prst="rect">
             <a:avLst/>
@@ -7063,7 +7063,7 @@
           <a:p>
             <a:pPr algn="l"/>
             <a:r>
-              <a:rPr sz="1590" b="1" i="0">
+              <a:rPr sz="1450" b="1" i="0">
                 <a:solidFill>
                   <a:srgbClr val="111111"/>
                 </a:solidFill>
@@ -7082,8 +7082,8 @@
         </p:nvCxnSpPr>
         <p:spPr>
           <a:xfrm>
-            <a:off x="6903720" y="3822192"/>
-            <a:ext cx="658368" cy="0"/>
+            <a:off x="6903720" y="3867912"/>
+            <a:ext cx="822959" cy="0"/>
           </a:xfrm>
           <a:prstGeom prst="line">
             <a:avLst/>
@@ -7104,8 +7104,8 @@
         </p:nvCxnSpPr>
         <p:spPr>
           <a:xfrm>
-            <a:off x="6903720" y="3675888"/>
-            <a:ext cx="658368" cy="0"/>
+            <a:off x="6903720" y="3721608"/>
+            <a:ext cx="822959" cy="0"/>
           </a:xfrm>
           <a:prstGeom prst="line">
             <a:avLst/>
@@ -7126,8 +7126,8 @@
         </p:nvCxnSpPr>
         <p:spPr>
           <a:xfrm>
-            <a:off x="6903720" y="3529584"/>
-            <a:ext cx="658368" cy="0"/>
+            <a:off x="6903720" y="3575304"/>
+            <a:ext cx="822959" cy="0"/>
           </a:xfrm>
           <a:prstGeom prst="line">
             <a:avLst/>
@@ -7148,8 +7148,8 @@
         </p:nvCxnSpPr>
         <p:spPr>
           <a:xfrm>
-            <a:off x="6903720" y="3383280"/>
-            <a:ext cx="658368" cy="0"/>
+            <a:off x="6903720" y="3429000"/>
+            <a:ext cx="822959" cy="0"/>
           </a:xfrm>
           <a:prstGeom prst="line">
             <a:avLst/>
@@ -7170,8 +7170,8 @@
         </p:nvCxnSpPr>
         <p:spPr>
           <a:xfrm>
-            <a:off x="6903720" y="3840480"/>
-            <a:ext cx="658368" cy="0"/>
+            <a:off x="6903720" y="3886200"/>
+            <a:ext cx="822960" cy="0"/>
           </a:xfrm>
           <a:prstGeom prst="line">
             <a:avLst/>
@@ -7193,7 +7193,7 @@
         <p:spPr>
           <a:xfrm>
             <a:off x="6949440" y="3337560"/>
-            <a:ext cx="155448" cy="502920"/>
+            <a:ext cx="201168" cy="548640"/>
           </a:xfrm>
           <a:prstGeom prst="rect">
             <a:avLst/>
@@ -7224,8 +7224,8 @@
         </p:nvSpPr>
         <p:spPr>
           <a:xfrm>
-            <a:off x="7155179" y="3511296"/>
-            <a:ext cx="155448" cy="329184"/>
+            <a:off x="7214616" y="3520440"/>
+            <a:ext cx="201168" cy="365760"/>
           </a:xfrm>
           <a:prstGeom prst="rect">
             <a:avLst/>
@@ -7256,8 +7256,8 @@
         </p:nvSpPr>
         <p:spPr>
           <a:xfrm>
-            <a:off x="7360919" y="3639312"/>
-            <a:ext cx="155448" cy="201168"/>
+            <a:off x="7479792" y="3657600"/>
+            <a:ext cx="201168" cy="228600"/>
           </a:xfrm>
           <a:prstGeom prst="rect">
             <a:avLst/>
@@ -7288,8 +7288,8 @@
         </p:nvCxnSpPr>
         <p:spPr>
           <a:xfrm>
-            <a:off x="7955279" y="3611880"/>
-            <a:ext cx="548641" cy="0"/>
+            <a:off x="8092440" y="3657600"/>
+            <a:ext cx="457200" cy="0"/>
           </a:xfrm>
           <a:prstGeom prst="line">
             <a:avLst/>
@@ -7311,8 +7311,8 @@
         </p:nvCxnSpPr>
         <p:spPr>
           <a:xfrm>
-            <a:off x="8595359" y="3822192"/>
-            <a:ext cx="658369" cy="0"/>
+            <a:off x="8641080" y="3867912"/>
+            <a:ext cx="822960" cy="0"/>
           </a:xfrm>
           <a:prstGeom prst="line">
             <a:avLst/>
@@ -7333,8 +7333,8 @@
         </p:nvCxnSpPr>
         <p:spPr>
           <a:xfrm>
-            <a:off x="8595359" y="3675888"/>
-            <a:ext cx="658369" cy="0"/>
+            <a:off x="8641080" y="3721608"/>
+            <a:ext cx="822960" cy="0"/>
           </a:xfrm>
           <a:prstGeom prst="line">
             <a:avLst/>
@@ -7355,8 +7355,8 @@
         </p:nvCxnSpPr>
         <p:spPr>
           <a:xfrm>
-            <a:off x="8595359" y="3529584"/>
-            <a:ext cx="658369" cy="0"/>
+            <a:off x="8641080" y="3575304"/>
+            <a:ext cx="822960" cy="0"/>
           </a:xfrm>
           <a:prstGeom prst="line">
             <a:avLst/>
@@ -7377,8 +7377,8 @@
         </p:nvCxnSpPr>
         <p:spPr>
           <a:xfrm>
-            <a:off x="8595359" y="3383280"/>
-            <a:ext cx="658369" cy="0"/>
+            <a:off x="8641080" y="3429000"/>
+            <a:ext cx="822960" cy="0"/>
           </a:xfrm>
           <a:prstGeom prst="line">
             <a:avLst/>
@@ -7399,8 +7399,8 @@
         </p:nvCxnSpPr>
         <p:spPr>
           <a:xfrm>
-            <a:off x="8595359" y="3840480"/>
-            <a:ext cx="658369" cy="0"/>
+            <a:off x="8641080" y="3886200"/>
+            <a:ext cx="822960" cy="0"/>
           </a:xfrm>
           <a:prstGeom prst="line">
             <a:avLst/>
@@ -7421,8 +7421,8 @@
         </p:nvSpPr>
         <p:spPr>
           <a:xfrm>
-            <a:off x="8641080" y="3712464"/>
-            <a:ext cx="155448" cy="128016"/>
+            <a:off x="8686800" y="3749039"/>
+            <a:ext cx="201168" cy="137160"/>
           </a:xfrm>
           <a:prstGeom prst="rect">
             <a:avLst/>
@@ -7453,8 +7453,8 @@
         </p:nvSpPr>
         <p:spPr>
           <a:xfrm>
-            <a:off x="8846819" y="3758184"/>
-            <a:ext cx="155448" cy="82296"/>
+            <a:off x="8951976" y="3794760"/>
+            <a:ext cx="201168" cy="91440"/>
           </a:xfrm>
           <a:prstGeom prst="rect">
             <a:avLst/>
@@ -7485,8 +7485,8 @@
         </p:nvSpPr>
         <p:spPr>
           <a:xfrm>
-            <a:off x="9052559" y="3794760"/>
-            <a:ext cx="155448" cy="45720"/>
+            <a:off x="9217152" y="3831336"/>
+            <a:ext cx="201168" cy="54864"/>
           </a:xfrm>
           <a:prstGeom prst="rect">
             <a:avLst/>
@@ -7588,7 +7588,7 @@
         <p:spPr>
           <a:xfrm>
             <a:off x="6172200" y="4169663"/>
-            <a:ext cx="365760" cy="365760"/>
+            <a:ext cx="457200" cy="457200"/>
           </a:xfrm>
           <a:prstGeom prst="ellipse">
             <a:avLst/>
@@ -7607,7 +7607,7 @@
           <a:p>
             <a:pPr algn="ctr"/>
             <a:r>
-              <a:rPr sz="1950" b="1" i="0">
+              <a:rPr sz="2200" b="1" i="0">
                 <a:solidFill>
                   <a:srgbClr val="FFFFFF"/>
                 </a:solidFill>
@@ -7626,8 +7626,8 @@
         </p:nvSpPr>
         <p:spPr>
           <a:xfrm>
-            <a:off x="6601968" y="4224528"/>
-            <a:ext cx="2926080" cy="292608"/>
+            <a:off x="6748272" y="4242816"/>
+            <a:ext cx="2834640" cy="292608"/>
           </a:xfrm>
           <a:prstGeom prst="rect">
             <a:avLst/>
@@ -7642,7 +7642,7 @@
           <a:p>
             <a:pPr algn="l"/>
             <a:r>
-              <a:rPr sz="1900" b="1" i="1">
+              <a:rPr sz="1800" b="1" i="1">
                 <a:solidFill>
                   <a:srgbClr val="111111"/>
                 </a:solidFill>
@@ -7662,7 +7662,7 @@
         <p:spPr>
           <a:xfrm>
             <a:off x="9528048" y="4169663"/>
-            <a:ext cx="365760" cy="365760"/>
+            <a:ext cx="457200" cy="457200"/>
           </a:xfrm>
           <a:prstGeom prst="ellipse">
             <a:avLst/>
@@ -7681,7 +7681,7 @@
           <a:p>
             <a:pPr algn="ctr"/>
             <a:r>
-              <a:rPr sz="1950" b="1" i="0">
+              <a:rPr sz="2200" b="1" i="0">
                 <a:solidFill>
                   <a:srgbClr val="FFFFFF"/>
                 </a:solidFill>
@@ -7700,8 +7700,8 @@
         </p:nvSpPr>
         <p:spPr>
           <a:xfrm>
-            <a:off x="9985248" y="4224528"/>
-            <a:ext cx="2103120" cy="292608"/>
+            <a:off x="10058400" y="4242816"/>
+            <a:ext cx="2057400" cy="292608"/>
           </a:xfrm>
           <a:prstGeom prst="rect">
             <a:avLst/>
@@ -7716,7 +7716,7 @@
           <a:p>
             <a:pPr algn="l"/>
             <a:r>
-              <a:rPr sz="1900" b="1" i="1">
+              <a:rPr sz="1650" b="1" i="1">
                 <a:solidFill>
                   <a:srgbClr val="111111"/>
                 </a:solidFill>
@@ -7735,8 +7735,8 @@
         </p:nvSpPr>
         <p:spPr>
           <a:xfrm>
-            <a:off x="6355080" y="4709160"/>
-            <a:ext cx="694944" cy="365760"/>
+            <a:off x="6309360" y="4709160"/>
+            <a:ext cx="822960" cy="420624"/>
           </a:xfrm>
           <a:prstGeom prst="roundRect">
             <a:avLst>
@@ -7769,8 +7769,8 @@
         </p:nvSpPr>
         <p:spPr>
           <a:xfrm>
-            <a:off x="6428232" y="4809744"/>
-            <a:ext cx="402336" cy="45720"/>
+            <a:off x="6400800" y="4828032"/>
+            <a:ext cx="493776" cy="54864"/>
           </a:xfrm>
           <a:prstGeom prst="rect">
             <a:avLst/>
@@ -7799,8 +7799,8 @@
         </p:nvSpPr>
         <p:spPr>
           <a:xfrm>
-            <a:off x="7150608" y="4636008"/>
-            <a:ext cx="164592" cy="402336"/>
+            <a:off x="7242048" y="4636008"/>
+            <a:ext cx="201168" cy="457200"/>
           </a:xfrm>
           <a:prstGeom prst="rect">
             <a:avLst/>
@@ -7831,8 +7831,8 @@
         </p:nvSpPr>
         <p:spPr>
           <a:xfrm>
-            <a:off x="6355080" y="5166360"/>
-            <a:ext cx="694944" cy="365760"/>
+            <a:off x="6309360" y="5212080"/>
+            <a:ext cx="822960" cy="420624"/>
           </a:xfrm>
           <a:prstGeom prst="roundRect">
             <a:avLst>
@@ -7865,8 +7865,8 @@
         </p:nvSpPr>
         <p:spPr>
           <a:xfrm>
-            <a:off x="6428232" y="5266944"/>
-            <a:ext cx="402336" cy="45720"/>
+            <a:off x="6400800" y="5330952"/>
+            <a:ext cx="493776" cy="54864"/>
           </a:xfrm>
           <a:prstGeom prst="rect">
             <a:avLst/>
@@ -7895,8 +7895,8 @@
         </p:nvSpPr>
         <p:spPr>
           <a:xfrm>
-            <a:off x="7150608" y="5294376"/>
-            <a:ext cx="164592" cy="201168"/>
+            <a:off x="7242048" y="5358384"/>
+            <a:ext cx="201168" cy="237744"/>
           </a:xfrm>
           <a:prstGeom prst="rect">
             <a:avLst/>
@@ -7927,8 +7927,8 @@
         </p:nvSpPr>
         <p:spPr>
           <a:xfrm>
-            <a:off x="6355080" y="5623560"/>
-            <a:ext cx="694944" cy="365760"/>
+            <a:off x="6309360" y="5715000"/>
+            <a:ext cx="822960" cy="420624"/>
           </a:xfrm>
           <a:prstGeom prst="roundRect">
             <a:avLst>
@@ -7961,8 +7961,8 @@
         </p:nvSpPr>
         <p:spPr>
           <a:xfrm>
-            <a:off x="6428232" y="5724144"/>
-            <a:ext cx="402336" cy="45720"/>
+            <a:off x="6400800" y="5833872"/>
+            <a:ext cx="493776" cy="54864"/>
           </a:xfrm>
           <a:prstGeom prst="rect">
             <a:avLst/>
@@ -7991,8 +7991,8 @@
         </p:nvSpPr>
         <p:spPr>
           <a:xfrm>
-            <a:off x="7150608" y="5623560"/>
-            <a:ext cx="164592" cy="329184"/>
+            <a:off x="7242048" y="5715000"/>
+            <a:ext cx="201168" cy="384048"/>
           </a:xfrm>
           <a:prstGeom prst="rect">
             <a:avLst/>
@@ -8023,8 +8023,8 @@
         </p:nvSpPr>
         <p:spPr>
           <a:xfrm>
-            <a:off x="6126480" y="6144768"/>
-            <a:ext cx="1828800" cy="292608"/>
+            <a:off x="6144768" y="6291072"/>
+            <a:ext cx="2011680" cy="292608"/>
           </a:xfrm>
           <a:prstGeom prst="rect">
             <a:avLst/>
@@ -8039,13 +8039,13 @@
           <a:p>
             <a:pPr algn="ctr"/>
             <a:r>
-              <a:rPr sz="1400" b="1" i="1">
+              <a:rPr sz="1250" b="1" i="1">
                 <a:solidFill>
                   <a:srgbClr val="111111"/>
                 </a:solidFill>
                 <a:latin typeface="Times New Roman"/>
               </a:rPr>
-              <a:t>loss ∝ demand served</a:t>
+              <a:t>loss ∝ demand</a:t>
             </a:r>
           </a:p>
         </p:txBody>
@@ -8058,8 +8058,8 @@
         </p:nvCxnSpPr>
         <p:spPr>
           <a:xfrm>
-            <a:off x="7452360" y="5257800"/>
-            <a:ext cx="411480" cy="0"/>
+            <a:off x="7589520" y="5349240"/>
+            <a:ext cx="384048" cy="0"/>
           </a:xfrm>
           <a:prstGeom prst="line">
             <a:avLst/>
@@ -8081,8 +8081,8 @@
         </p:nvSpPr>
         <p:spPr>
           <a:xfrm>
-            <a:off x="7772400" y="4764024"/>
-            <a:ext cx="1005840" cy="896112"/>
+            <a:off x="8023859" y="4809744"/>
+            <a:ext cx="1234440" cy="1078992"/>
           </a:xfrm>
           <a:prstGeom prst="roundRect">
             <a:avLst>
@@ -8115,7 +8115,7 @@
         </p:nvSpPr>
         <p:spPr>
           <a:xfrm>
-            <a:off x="8264347" y="4636008"/>
+            <a:off x="8630107" y="4681728"/>
             <a:ext cx="21945" cy="128016"/>
           </a:xfrm>
           <a:prstGeom prst="rect">
@@ -8145,7 +8145,7 @@
         </p:nvSpPr>
         <p:spPr>
           <a:xfrm>
-            <a:off x="8229600" y="4544568"/>
+            <a:off x="8595359" y="4590288"/>
             <a:ext cx="91440" cy="91440"/>
           </a:xfrm>
           <a:prstGeom prst="ellipse">
@@ -8175,7 +8175,7 @@
         </p:nvSpPr>
         <p:spPr>
           <a:xfrm>
-            <a:off x="8053120" y="5081320"/>
+            <a:off x="8377732" y="5200192"/>
             <a:ext cx="82296" cy="82296"/>
           </a:xfrm>
           <a:prstGeom prst="ellipse">
@@ -8205,7 +8205,7 @@
         </p:nvSpPr>
         <p:spPr>
           <a:xfrm>
-            <a:off x="8415223" y="5081320"/>
+            <a:off x="8822131" y="5200192"/>
             <a:ext cx="82296" cy="82296"/>
           </a:xfrm>
           <a:prstGeom prst="ellipse">
@@ -8235,8 +8235,8 @@
         </p:nvSpPr>
         <p:spPr>
           <a:xfrm>
-            <a:off x="8134502" y="5319613"/>
-            <a:ext cx="281635" cy="27432"/>
+            <a:off x="8468258" y="5478719"/>
+            <a:ext cx="345643" cy="27432"/>
           </a:xfrm>
           <a:prstGeom prst="roundRect">
             <a:avLst>
@@ -8267,8 +8267,8 @@
         </p:nvSpPr>
         <p:spPr>
           <a:xfrm>
-            <a:off x="7452360" y="5696712"/>
-            <a:ext cx="1645920" cy="256032"/>
+            <a:off x="7703819" y="5925312"/>
+            <a:ext cx="1874519" cy="256032"/>
           </a:xfrm>
           <a:prstGeom prst="rect">
             <a:avLst/>
@@ -8283,7 +8283,7 @@
           <a:p>
             <a:pPr algn="ctr"/>
             <a:r>
-              <a:rPr sz="1460" b="1" i="0">
+              <a:rPr sz="1500" b="1" i="0">
                 <a:solidFill>
                   <a:srgbClr val="1F1F1E"/>
                 </a:solidFill>
@@ -8302,7 +8302,7 @@
         </p:nvCxnSpPr>
         <p:spPr>
           <a:xfrm>
-            <a:off x="7818120" y="6419088"/>
+            <a:off x="6720840" y="6492240"/>
             <a:ext cx="1417320" cy="0"/>
           </a:xfrm>
           <a:prstGeom prst="line">
@@ -8324,7 +8324,7 @@
         </p:nvCxnSpPr>
         <p:spPr>
           <a:xfrm>
-            <a:off x="7818120" y="6272783"/>
+            <a:off x="6720840" y="6345936"/>
             <a:ext cx="1417320" cy="0"/>
           </a:xfrm>
           <a:prstGeom prst="line">
@@ -8346,7 +8346,7 @@
         </p:nvCxnSpPr>
         <p:spPr>
           <a:xfrm>
-            <a:off x="7818120" y="6126479"/>
+            <a:off x="6720840" y="6199631"/>
             <a:ext cx="1417320" cy="0"/>
           </a:xfrm>
           <a:prstGeom prst="line">
@@ -8368,8 +8368,8 @@
         </p:nvCxnSpPr>
         <p:spPr>
           <a:xfrm flipV="1">
-            <a:off x="7845552" y="6126480"/>
-            <a:ext cx="292608" cy="228600"/>
+            <a:off x="6748272" y="6236208"/>
+            <a:ext cx="292608" cy="192024"/>
           </a:xfrm>
           <a:prstGeom prst="line">
             <a:avLst/>
@@ -8390,8 +8390,8 @@
         </p:nvCxnSpPr>
         <p:spPr>
           <a:xfrm flipV="1">
-            <a:off x="8138160" y="5925312"/>
-            <a:ext cx="320040" cy="201168"/>
+            <a:off x="7040880" y="6053328"/>
+            <a:ext cx="320040" cy="182880"/>
           </a:xfrm>
           <a:prstGeom prst="line">
             <a:avLst/>
@@ -8412,7 +8412,7 @@
         </p:nvCxnSpPr>
         <p:spPr>
           <a:xfrm flipV="1">
-            <a:off x="8458200" y="5870448"/>
+            <a:off x="7360920" y="5998464"/>
             <a:ext cx="274320" cy="54864"/>
           </a:xfrm>
           <a:prstGeom prst="line">
@@ -8434,8 +8434,8 @@
         </p:nvCxnSpPr>
         <p:spPr>
           <a:xfrm>
-            <a:off x="8732520" y="5870448"/>
-            <a:ext cx="274320" cy="118872"/>
+            <a:off x="7635240" y="5998464"/>
+            <a:ext cx="274320" cy="109728"/>
           </a:xfrm>
           <a:prstGeom prst="line">
             <a:avLst/>
@@ -8456,7 +8456,7 @@
         </p:nvSpPr>
         <p:spPr>
           <a:xfrm>
-            <a:off x="8659368" y="5797296"/>
+            <a:off x="7562088" y="5925312"/>
             <a:ext cx="155448" cy="155448"/>
           </a:xfrm>
           <a:prstGeom prst="ellipse">
@@ -8488,7 +8488,7 @@
         </p:nvSpPr>
         <p:spPr>
           <a:xfrm>
-            <a:off x="7589520" y="6455664"/>
+            <a:off x="6537960" y="6510528"/>
             <a:ext cx="2011680" cy="292608"/>
           </a:xfrm>
           <a:prstGeom prst="rect">
@@ -8504,7 +8504,7 @@
           <a:p>
             <a:pPr algn="ctr"/>
             <a:r>
-              <a:rPr sz="1340" b="1" i="1">
+              <a:rPr sz="1200" b="1" i="1">
                 <a:solidFill>
                   <a:srgbClr val="111111"/>
                 </a:solidFill>
@@ -8557,8 +8557,8 @@
         </p:nvSpPr>
         <p:spPr>
           <a:xfrm>
-            <a:off x="9802368" y="4773168"/>
-            <a:ext cx="603504" cy="603504"/>
+            <a:off x="9784080" y="4736592"/>
+            <a:ext cx="713232" cy="713232"/>
           </a:xfrm>
           <a:prstGeom prst="ellipse">
             <a:avLst/>
@@ -8680,8 +8680,8 @@
         </p:nvSpPr>
         <p:spPr>
           <a:xfrm>
-            <a:off x="9829800" y="5989320"/>
-            <a:ext cx="457200" cy="457200"/>
+            <a:off x="9784080" y="5961888"/>
+            <a:ext cx="548640" cy="548640"/>
           </a:xfrm>
           <a:prstGeom prst="diamond">
             <a:avLst/>
@@ -8782,8 +8782,8 @@
         </p:nvCxnSpPr>
         <p:spPr>
           <a:xfrm>
-            <a:off x="9326880" y="6217920"/>
-            <a:ext cx="438912" cy="0"/>
+            <a:off x="9281160" y="6236208"/>
+            <a:ext cx="429768" cy="0"/>
           </a:xfrm>
           <a:prstGeom prst="line">
             <a:avLst/>

</xml_diff>